<commit_message>
Trabalhos: publica versao do modelo revisada pela Sabrina
Substitui o .pptx pela versao editada manualmente (capa com o tempo em
caixa lateral destacada + instrucao "Apague esta caixa de texto"), que
e a versao canonica mantida em Documents\ABENFORJ.

Co-Authored-By: Claude Opus 4.8 (1M context) <noreply@anthropic.com>
</commit_message>
<xml_diff>
--- a/downloads/modelo-apresentacao-trabalhos-ix-eneon.pptx
+++ b/downloads/modelo-apresentacao-trabalhos-ix-eneon.pptx
@@ -4,15 +4,18 @@
   <p:sldMasterIdLst>
     <p:sldMasterId id="2147483648" r:id="rId1"/>
   </p:sldMasterIdLst>
+  <p:notesMasterIdLst>
+    <p:notesMasterId r:id="rId8"/>
+  </p:notesMasterIdLst>
   <p:sldIdLst>
-    <p:sldId id="256" r:id="rId7"/>
-    <p:sldId id="257" r:id="rId9"/>
-    <p:sldId id="258" r:id="rId10"/>
-    <p:sldId id="259" r:id="rId11"/>
-    <p:sldId id="260" r:id="rId12"/>
-    <p:sldId id="261" r:id="rId13"/>
+    <p:sldId id="256" r:id="rId2"/>
+    <p:sldId id="257" r:id="rId3"/>
+    <p:sldId id="258" r:id="rId4"/>
+    <p:sldId id="259" r:id="rId5"/>
+    <p:sldId id="260" r:id="rId6"/>
+    <p:sldId id="261" r:id="rId7"/>
   </p:sldIdLst>
-  <p:sldSz cx="12191695" cy="6858000" type="screen4x3"/>
+  <p:sldSz cx="12192000" cy="6858000"/>
   <p:notesSz cx="6858000" cy="9144000"/>
   <p:defaultTextStyle>
     <a:defPPr>
@@ -109,11 +112,27 @@
       </a:defRPr>
     </a:lvl9pPr>
   </p:defaultTextStyle>
+  <p:extLst>
+    <p:ext uri="{EFAFB233-063F-42B5-8137-9DF3F51BA10A}">
+      <p15:sldGuideLst xmlns:p15="http://schemas.microsoft.com/office/powerpoint/2012/main">
+        <p15:guide id="1" orient="horz" pos="2160">
+          <p15:clr>
+            <a:srgbClr val="A4A3A4"/>
+          </p15:clr>
+        </p15:guide>
+        <p15:guide id="2" pos="2880">
+          <p15:clr>
+            <a:srgbClr val="A4A3A4"/>
+          </p15:clr>
+        </p15:guide>
+      </p15:sldGuideLst>
+    </p:ext>
+  </p:extLst>
 </p:presentation>
 </file>
 
 <file path=ppt/notesMasters/notesMaster1.xml><?xml version="1.0" encoding="utf-8"?>
-<p:notesMaster xmlns:a="http://schemas.openxmlformats.org/drawingml/2006/main" xmlns:p="http://schemas.openxmlformats.org/presentationml/2006/main" xmlns:r="http://schemas.openxmlformats.org/officeDocument/2006/relationships">
+<p:notesMaster xmlns:a="http://schemas.openxmlformats.org/drawingml/2006/main" xmlns:r="http://schemas.openxmlformats.org/officeDocument/2006/relationships" xmlns:p="http://schemas.openxmlformats.org/presentationml/2006/main">
   <p:cSld>
     <p:bg>
       <p:bgRef idx="1001">
@@ -134,241 +153,16 @@
           <a:chExt cx="0" cy="0"/>
         </a:xfrm>
       </p:grpSpPr>
-      <p:sp>
-        <p:nvSpPr>
-          <p:cNvPr id="2" name="Header Placeholder 1"/>
-          <p:cNvSpPr>
-            <a:spLocks noGrp="1"/>
-          </p:cNvSpPr>
-          <p:nvPr>
-            <p:ph type="hdr" sz="quarter"/>
-          </p:nvPr>
-        </p:nvSpPr>
-        <p:spPr>
-          <a:xfrm>
-            <a:off x="0" y="0"/>
-            <a:ext cx="2971800" cy="457200"/>
-          </a:xfrm>
-          <a:prstGeom prst="rect">
-            <a:avLst/>
-          </a:prstGeom>
-        </p:spPr>
-        <p:txBody>
-          <a:bodyPr vert="horz" lIns="91440" tIns="45720" rIns="91440" bIns="45720" rtlCol="0"/>
-          <a:lstStyle>
-            <a:lvl1pPr algn="l">
-              <a:defRPr sz="1200"/>
-            </a:lvl1pPr>
-          </a:lstStyle>
-          <a:p>
-            <a:endParaRPr lang="en-US"/>
-          </a:p>
-        </p:txBody>
-      </p:sp>
-      <p:sp>
-        <p:nvSpPr>
-          <p:cNvPr id="3" name="Date Placeholder 2"/>
-          <p:cNvSpPr>
-            <a:spLocks noGrp="1"/>
-          </p:cNvSpPr>
-          <p:nvPr>
-            <p:ph type="dt" idx="1"/>
-          </p:nvPr>
-        </p:nvSpPr>
-        <p:spPr>
-          <a:xfrm>
-            <a:off x="3884613" y="0"/>
-            <a:ext cx="2971800" cy="457200"/>
-          </a:xfrm>
-          <a:prstGeom prst="rect">
-            <a:avLst/>
-          </a:prstGeom>
-        </p:spPr>
-        <p:txBody>
-          <a:bodyPr vert="horz" lIns="91440" tIns="45720" rIns="91440" bIns="45720" rtlCol="0"/>
-          <a:lstStyle>
-            <a:lvl1pPr algn="r">
-              <a:defRPr sz="1200"/>
-            </a:lvl1pPr>
-          </a:lstStyle>
-          <a:p>
-            <a:fld id="{0F89C1C7-3DCD-1040-A9CF-14679D8B5DDD}" type="datetimeFigureOut">
-              <a:rPr lang="en-US" smtClean="0"/>
-              <a:t>10/17/16</a:t>
-            </a:fld>
-            <a:endParaRPr lang="en-US"/>
-          </a:p>
-        </p:txBody>
-      </p:sp>
-      <p:sp>
-        <p:nvSpPr>
-          <p:cNvPr id="4" name="Slide Image Placeholder 3"/>
-          <p:cNvSpPr>
-            <a:spLocks noGrp="1" noRot="1" noChangeAspect="1"/>
-          </p:cNvSpPr>
-          <p:nvPr>
-            <p:ph type="sldImg" idx="2"/>
-          </p:nvPr>
-        </p:nvSpPr>
-        <p:spPr>
-          <a:xfrm>
-            <a:off x="1143000" y="685800"/>
-            <a:ext cx="4572000" cy="3429000"/>
-          </a:xfrm>
-          <a:prstGeom prst="rect">
-            <a:avLst/>
-          </a:prstGeom>
-          <a:noFill/>
-          <a:ln w="12700">
-            <a:solidFill>
-              <a:prstClr val="black"/>
-            </a:solidFill>
-          </a:ln>
-        </p:spPr>
-        <p:txBody>
-          <a:bodyPr vert="horz" lIns="91440" tIns="45720" rIns="91440" bIns="45720" rtlCol="0" anchor="ctr"/>
-          <a:lstStyle/>
-          <a:p>
-            <a:endParaRPr lang="en-US"/>
-          </a:p>
-        </p:txBody>
-      </p:sp>
-      <p:sp>
-        <p:nvSpPr>
-          <p:cNvPr id="5" name="Notes Placeholder 4"/>
-          <p:cNvSpPr>
-            <a:spLocks noGrp="1"/>
-          </p:cNvSpPr>
-          <p:nvPr>
-            <p:ph type="body" sz="quarter" idx="3"/>
-          </p:nvPr>
-        </p:nvSpPr>
-        <p:spPr>
-          <a:xfrm>
-            <a:off x="685800" y="4343400"/>
-            <a:ext cx="5486400" cy="4114800"/>
-          </a:xfrm>
-          <a:prstGeom prst="rect">
-            <a:avLst/>
-          </a:prstGeom>
-        </p:spPr>
-        <p:txBody>
-          <a:bodyPr vert="horz" lIns="91440" tIns="45720" rIns="91440" bIns="45720" rtlCol="0"/>
-          <a:lstStyle/>
-          <a:p>
-            <a:pPr lvl="0"/>
-            <a:r>
-              <a:rPr lang="en-US" smtClean="0"/>
-              <a:t>Click to edit Master text styles</a:t>
-            </a:r>
-          </a:p>
-          <a:p>
-            <a:pPr lvl="1"/>
-            <a:r>
-              <a:rPr lang="en-US" smtClean="0"/>
-              <a:t>Second level</a:t>
-            </a:r>
-          </a:p>
-          <a:p>
-            <a:pPr lvl="2"/>
-            <a:r>
-              <a:rPr lang="en-US" smtClean="0"/>
-              <a:t>Third level</a:t>
-            </a:r>
-          </a:p>
-          <a:p>
-            <a:pPr lvl="3"/>
-            <a:r>
-              <a:rPr lang="en-US" smtClean="0"/>
-              <a:t>Fourth level</a:t>
-            </a:r>
-          </a:p>
-          <a:p>
-            <a:pPr lvl="4"/>
-            <a:r>
-              <a:rPr lang="en-US" smtClean="0"/>
-              <a:t>Fifth level</a:t>
-            </a:r>
-            <a:endParaRPr lang="en-US"/>
-          </a:p>
-        </p:txBody>
-      </p:sp>
-      <p:sp>
-        <p:nvSpPr>
-          <p:cNvPr id="6" name="Footer Placeholder 5"/>
-          <p:cNvSpPr>
-            <a:spLocks noGrp="1"/>
-          </p:cNvSpPr>
-          <p:nvPr>
-            <p:ph type="ftr" sz="quarter" idx="4"/>
-          </p:nvPr>
-        </p:nvSpPr>
-        <p:spPr>
-          <a:xfrm>
-            <a:off x="0" y="8685213"/>
-            <a:ext cx="2971800" cy="457200"/>
-          </a:xfrm>
-          <a:prstGeom prst="rect">
-            <a:avLst/>
-          </a:prstGeom>
-        </p:spPr>
-        <p:txBody>
-          <a:bodyPr vert="horz" lIns="91440" tIns="45720" rIns="91440" bIns="45720" rtlCol="0" anchor="b"/>
-          <a:lstStyle>
-            <a:lvl1pPr algn="l">
-              <a:defRPr sz="1200"/>
-            </a:lvl1pPr>
-          </a:lstStyle>
-          <a:p>
-            <a:endParaRPr lang="en-US"/>
-          </a:p>
-        </p:txBody>
-      </p:sp>
-      <p:sp>
-        <p:nvSpPr>
-          <p:cNvPr id="7" name="Slide Number Placeholder 6"/>
-          <p:cNvSpPr>
-            <a:spLocks noGrp="1"/>
-          </p:cNvSpPr>
-          <p:nvPr>
-            <p:ph type="sldNum" sz="quarter" idx="5"/>
-          </p:nvPr>
-        </p:nvSpPr>
-        <p:spPr>
-          <a:xfrm>
-            <a:off x="3884613" y="8685213"/>
-            <a:ext cx="2971800" cy="457200"/>
-          </a:xfrm>
-          <a:prstGeom prst="rect">
-            <a:avLst/>
-          </a:prstGeom>
-        </p:spPr>
-        <p:txBody>
-          <a:bodyPr vert="horz" lIns="91440" tIns="45720" rIns="91440" bIns="45720" rtlCol="0" anchor="b"/>
-          <a:lstStyle>
-            <a:lvl1pPr algn="r">
-              <a:defRPr sz="1200"/>
-            </a:lvl1pPr>
-          </a:lstStyle>
-          <a:p>
-            <a:fld id="{BB5E49A5-4136-284D-997B-48E1D791AD67}" type="slidenum">
-              <a:rPr lang="en-US" smtClean="0"/>
-              <a:t>‹#›</a:t>
-            </a:fld>
-            <a:endParaRPr lang="en-US"/>
-          </a:p>
-        </p:txBody>
-      </p:sp>
     </p:spTree>
     <p:extLst>
       <p:ext uri="{BB962C8B-B14F-4D97-AF65-F5344CB8AC3E}">
-        <p14:creationId xmlns:p14="http://schemas.microsoft.com/office/powerpoint/2010/main" val="2623252185"/>
+        <p14:creationId xmlns:p14="http://schemas.microsoft.com/office/powerpoint/2010/main" val="3462948730"/>
       </p:ext>
     </p:extLst>
   </p:cSld>
   <p:clrMap bg1="lt1" tx1="dk1" bg2="lt2" tx2="dk2" accent1="accent1" accent2="accent2" accent3="accent3" accent4="accent4" accent5="accent5" accent6="accent6" hlink="hlink" folHlink="folHlink"/>
   <p:notesStyle>
-    <a:lvl1pPr marL="0" algn="l" defTabSz="457200" rtl="0" eaLnBrk="1" latinLnBrk="0" hangingPunct="1">
+    <a:lvl1pPr marL="0" algn="l" defTabSz="914400" rtl="0" eaLnBrk="1" latinLnBrk="0" hangingPunct="1">
       <a:defRPr sz="1200" kern="1200">
         <a:solidFill>
           <a:schemeClr val="tx1"/>
@@ -378,7 +172,7 @@
         <a:cs typeface="+mn-cs"/>
       </a:defRPr>
     </a:lvl1pPr>
-    <a:lvl2pPr marL="457200" algn="l" defTabSz="457200" rtl="0" eaLnBrk="1" latinLnBrk="0" hangingPunct="1">
+    <a:lvl2pPr marL="457200" algn="l" defTabSz="914400" rtl="0" eaLnBrk="1" latinLnBrk="0" hangingPunct="1">
       <a:defRPr sz="1200" kern="1200">
         <a:solidFill>
           <a:schemeClr val="tx1"/>
@@ -388,7 +182,7 @@
         <a:cs typeface="+mn-cs"/>
       </a:defRPr>
     </a:lvl2pPr>
-    <a:lvl3pPr marL="914400" algn="l" defTabSz="457200" rtl="0" eaLnBrk="1" latinLnBrk="0" hangingPunct="1">
+    <a:lvl3pPr marL="914400" algn="l" defTabSz="914400" rtl="0" eaLnBrk="1" latinLnBrk="0" hangingPunct="1">
       <a:defRPr sz="1200" kern="1200">
         <a:solidFill>
           <a:schemeClr val="tx1"/>
@@ -398,7 +192,7 @@
         <a:cs typeface="+mn-cs"/>
       </a:defRPr>
     </a:lvl3pPr>
-    <a:lvl4pPr marL="1371600" algn="l" defTabSz="457200" rtl="0" eaLnBrk="1" latinLnBrk="0" hangingPunct="1">
+    <a:lvl4pPr marL="1371600" algn="l" defTabSz="914400" rtl="0" eaLnBrk="1" latinLnBrk="0" hangingPunct="1">
       <a:defRPr sz="1200" kern="1200">
         <a:solidFill>
           <a:schemeClr val="tx1"/>
@@ -408,7 +202,7 @@
         <a:cs typeface="+mn-cs"/>
       </a:defRPr>
     </a:lvl4pPr>
-    <a:lvl5pPr marL="1828800" algn="l" defTabSz="457200" rtl="0" eaLnBrk="1" latinLnBrk="0" hangingPunct="1">
+    <a:lvl5pPr marL="1828800" algn="l" defTabSz="914400" rtl="0" eaLnBrk="1" latinLnBrk="0" hangingPunct="1">
       <a:defRPr sz="1200" kern="1200">
         <a:solidFill>
           <a:schemeClr val="tx1"/>
@@ -418,7 +212,7 @@
         <a:cs typeface="+mn-cs"/>
       </a:defRPr>
     </a:lvl5pPr>
-    <a:lvl6pPr marL="2286000" algn="l" defTabSz="457200" rtl="0" eaLnBrk="1" latinLnBrk="0" hangingPunct="1">
+    <a:lvl6pPr marL="2286000" algn="l" defTabSz="914400" rtl="0" eaLnBrk="1" latinLnBrk="0" hangingPunct="1">
       <a:defRPr sz="1200" kern="1200">
         <a:solidFill>
           <a:schemeClr val="tx1"/>
@@ -428,7 +222,7 @@
         <a:cs typeface="+mn-cs"/>
       </a:defRPr>
     </a:lvl6pPr>
-    <a:lvl7pPr marL="2743200" algn="l" defTabSz="457200" rtl="0" eaLnBrk="1" latinLnBrk="0" hangingPunct="1">
+    <a:lvl7pPr marL="2743200" algn="l" defTabSz="914400" rtl="0" eaLnBrk="1" latinLnBrk="0" hangingPunct="1">
       <a:defRPr sz="1200" kern="1200">
         <a:solidFill>
           <a:schemeClr val="tx1"/>
@@ -438,7 +232,7 @@
         <a:cs typeface="+mn-cs"/>
       </a:defRPr>
     </a:lvl7pPr>
-    <a:lvl8pPr marL="3200400" algn="l" defTabSz="457200" rtl="0" eaLnBrk="1" latinLnBrk="0" hangingPunct="1">
+    <a:lvl8pPr marL="3200400" algn="l" defTabSz="914400" rtl="0" eaLnBrk="1" latinLnBrk="0" hangingPunct="1">
       <a:defRPr sz="1200" kern="1200">
         <a:solidFill>
           <a:schemeClr val="tx1"/>
@@ -448,7 +242,7 @@
         <a:cs typeface="+mn-cs"/>
       </a:defRPr>
     </a:lvl8pPr>
-    <a:lvl9pPr marL="3657600" algn="l" defTabSz="457200" rtl="0" eaLnBrk="1" latinLnBrk="0" hangingPunct="1">
+    <a:lvl9pPr marL="3657600" algn="l" defTabSz="914400" rtl="0" eaLnBrk="1" latinLnBrk="0" hangingPunct="1">
       <a:defRPr sz="1200" kern="1200">
         <a:solidFill>
           <a:schemeClr val="tx1"/>
@@ -463,7 +257,7 @@
 </file>
 
 <file path=ppt/notesSlides/notesSlide1.xml><?xml version="1.0" encoding="utf-8"?>
-<p:notes xmlns:a="http://schemas.openxmlformats.org/drawingml/2006/main" xmlns:p="http://schemas.openxmlformats.org/presentationml/2006/main" xmlns:r="http://schemas.openxmlformats.org/officeDocument/2006/relationships">
+<p:notes xmlns:a="http://schemas.openxmlformats.org/drawingml/2006/main" xmlns:r="http://schemas.openxmlformats.org/officeDocument/2006/relationships" xmlns:p="http://schemas.openxmlformats.org/presentationml/2006/main">
   <p:cSld>
     <p:spTree>
       <p:nvGrpSpPr>
@@ -483,7 +277,7 @@
         <p:nvSpPr>
           <p:cNvPr id="2" name="Slide Image Placeholder 1"/>
           <p:cNvSpPr>
-            <a:spLocks noGrp="1"/>
+            <a:spLocks noGrp="1" noRot="1" noChangeAspect="1"/>
           </p:cNvSpPr>
           <p:nvPr>
             <p:ph type="sldImg" idx="2"/>
@@ -498,7 +292,7 @@
             <a:spLocks noGrp="1"/>
           </p:cNvSpPr>
           <p:nvPr>
-            <p:ph type="body" idx="3" sz="quarter"/>
+            <p:ph type="body" sz="quarter" idx="3"/>
           </p:nvPr>
         </p:nvSpPr>
         <p:spPr/>
@@ -519,7 +313,7 @@
             <a:spLocks noGrp="1"/>
           </p:cNvSpPr>
           <p:nvPr>
-            <p:ph type="sldNum" idx="5" sz="quarter"/>
+            <p:ph type="sldNum" sz="quarter" idx="5"/>
           </p:nvPr>
         </p:nvSpPr>
         <p:spPr/>
@@ -533,7 +327,7 @@
 </file>
 
 <file path=ppt/notesSlides/notesSlide2.xml><?xml version="1.0" encoding="utf-8"?>
-<p:notes xmlns:a="http://schemas.openxmlformats.org/drawingml/2006/main" xmlns:p="http://schemas.openxmlformats.org/presentationml/2006/main" xmlns:r="http://schemas.openxmlformats.org/officeDocument/2006/relationships">
+<p:notes xmlns:a="http://schemas.openxmlformats.org/drawingml/2006/main" xmlns:r="http://schemas.openxmlformats.org/officeDocument/2006/relationships" xmlns:p="http://schemas.openxmlformats.org/presentationml/2006/main">
   <p:cSld>
     <p:spTree>
       <p:nvGrpSpPr>
@@ -553,7 +347,7 @@
         <p:nvSpPr>
           <p:cNvPr id="2" name="Slide Image Placeholder 1"/>
           <p:cNvSpPr>
-            <a:spLocks noGrp="1"/>
+            <a:spLocks noGrp="1" noRot="1" noChangeAspect="1"/>
           </p:cNvSpPr>
           <p:nvPr>
             <p:ph type="sldImg" idx="2"/>
@@ -568,7 +362,7 @@
             <a:spLocks noGrp="1"/>
           </p:cNvSpPr>
           <p:nvPr>
-            <p:ph type="body" idx="3" sz="quarter"/>
+            <p:ph type="body" sz="quarter" idx="3"/>
           </p:nvPr>
         </p:nvSpPr>
         <p:spPr/>
@@ -589,7 +383,7 @@
             <a:spLocks noGrp="1"/>
           </p:cNvSpPr>
           <p:nvPr>
-            <p:ph type="sldNum" idx="5" sz="quarter"/>
+            <p:ph type="sldNum" sz="quarter" idx="5"/>
           </p:nvPr>
         </p:nvSpPr>
         <p:spPr/>
@@ -603,7 +397,7 @@
 </file>
 
 <file path=ppt/notesSlides/notesSlide3.xml><?xml version="1.0" encoding="utf-8"?>
-<p:notes xmlns:a="http://schemas.openxmlformats.org/drawingml/2006/main" xmlns:p="http://schemas.openxmlformats.org/presentationml/2006/main" xmlns:r="http://schemas.openxmlformats.org/officeDocument/2006/relationships">
+<p:notes xmlns:a="http://schemas.openxmlformats.org/drawingml/2006/main" xmlns:r="http://schemas.openxmlformats.org/officeDocument/2006/relationships" xmlns:p="http://schemas.openxmlformats.org/presentationml/2006/main">
   <p:cSld>
     <p:spTree>
       <p:nvGrpSpPr>
@@ -623,7 +417,7 @@
         <p:nvSpPr>
           <p:cNvPr id="2" name="Slide Image Placeholder 1"/>
           <p:cNvSpPr>
-            <a:spLocks noGrp="1"/>
+            <a:spLocks noGrp="1" noRot="1" noChangeAspect="1"/>
           </p:cNvSpPr>
           <p:nvPr>
             <p:ph type="sldImg" idx="2"/>
@@ -638,7 +432,7 @@
             <a:spLocks noGrp="1"/>
           </p:cNvSpPr>
           <p:nvPr>
-            <p:ph type="body" idx="3" sz="quarter"/>
+            <p:ph type="body" sz="quarter" idx="3"/>
           </p:nvPr>
         </p:nvSpPr>
         <p:spPr/>
@@ -659,7 +453,7 @@
             <a:spLocks noGrp="1"/>
           </p:cNvSpPr>
           <p:nvPr>
-            <p:ph type="sldNum" idx="5" sz="quarter"/>
+            <p:ph type="sldNum" sz="quarter" idx="5"/>
           </p:nvPr>
         </p:nvSpPr>
         <p:spPr/>
@@ -673,7 +467,7 @@
 </file>
 
 <file path=ppt/notesSlides/notesSlide4.xml><?xml version="1.0" encoding="utf-8"?>
-<p:notes xmlns:a="http://schemas.openxmlformats.org/drawingml/2006/main" xmlns:p="http://schemas.openxmlformats.org/presentationml/2006/main" xmlns:r="http://schemas.openxmlformats.org/officeDocument/2006/relationships">
+<p:notes xmlns:a="http://schemas.openxmlformats.org/drawingml/2006/main" xmlns:r="http://schemas.openxmlformats.org/officeDocument/2006/relationships" xmlns:p="http://schemas.openxmlformats.org/presentationml/2006/main">
   <p:cSld>
     <p:spTree>
       <p:nvGrpSpPr>
@@ -693,7 +487,7 @@
         <p:nvSpPr>
           <p:cNvPr id="2" name="Slide Image Placeholder 1"/>
           <p:cNvSpPr>
-            <a:spLocks noGrp="1"/>
+            <a:spLocks noGrp="1" noRot="1" noChangeAspect="1"/>
           </p:cNvSpPr>
           <p:nvPr>
             <p:ph type="sldImg" idx="2"/>
@@ -708,7 +502,7 @@
             <a:spLocks noGrp="1"/>
           </p:cNvSpPr>
           <p:nvPr>
-            <p:ph type="body" idx="3" sz="quarter"/>
+            <p:ph type="body" sz="quarter" idx="3"/>
           </p:nvPr>
         </p:nvSpPr>
         <p:spPr/>
@@ -729,7 +523,7 @@
             <a:spLocks noGrp="1"/>
           </p:cNvSpPr>
           <p:nvPr>
-            <p:ph type="sldNum" idx="5" sz="quarter"/>
+            <p:ph type="sldNum" sz="quarter" idx="5"/>
           </p:nvPr>
         </p:nvSpPr>
         <p:spPr/>
@@ -743,7 +537,7 @@
 </file>
 
 <file path=ppt/notesSlides/notesSlide5.xml><?xml version="1.0" encoding="utf-8"?>
-<p:notes xmlns:a="http://schemas.openxmlformats.org/drawingml/2006/main" xmlns:p="http://schemas.openxmlformats.org/presentationml/2006/main" xmlns:r="http://schemas.openxmlformats.org/officeDocument/2006/relationships">
+<p:notes xmlns:a="http://schemas.openxmlformats.org/drawingml/2006/main" xmlns:r="http://schemas.openxmlformats.org/officeDocument/2006/relationships" xmlns:p="http://schemas.openxmlformats.org/presentationml/2006/main">
   <p:cSld>
     <p:spTree>
       <p:nvGrpSpPr>
@@ -763,7 +557,7 @@
         <p:nvSpPr>
           <p:cNvPr id="2" name="Slide Image Placeholder 1"/>
           <p:cNvSpPr>
-            <a:spLocks noGrp="1"/>
+            <a:spLocks noGrp="1" noRot="1" noChangeAspect="1"/>
           </p:cNvSpPr>
           <p:nvPr>
             <p:ph type="sldImg" idx="2"/>
@@ -778,7 +572,7 @@
             <a:spLocks noGrp="1"/>
           </p:cNvSpPr>
           <p:nvPr>
-            <p:ph type="body" idx="3" sz="quarter"/>
+            <p:ph type="body" sz="quarter" idx="3"/>
           </p:nvPr>
         </p:nvSpPr>
         <p:spPr/>
@@ -799,7 +593,7 @@
             <a:spLocks noGrp="1"/>
           </p:cNvSpPr>
           <p:nvPr>
-            <p:ph type="sldNum" idx="5" sz="quarter"/>
+            <p:ph type="sldNum" sz="quarter" idx="5"/>
           </p:nvPr>
         </p:nvSpPr>
         <p:spPr/>
@@ -813,7 +607,7 @@
 </file>
 
 <file path=ppt/notesSlides/notesSlide6.xml><?xml version="1.0" encoding="utf-8"?>
-<p:notes xmlns:a="http://schemas.openxmlformats.org/drawingml/2006/main" xmlns:p="http://schemas.openxmlformats.org/presentationml/2006/main" xmlns:r="http://schemas.openxmlformats.org/officeDocument/2006/relationships">
+<p:notes xmlns:a="http://schemas.openxmlformats.org/drawingml/2006/main" xmlns:r="http://schemas.openxmlformats.org/officeDocument/2006/relationships" xmlns:p="http://schemas.openxmlformats.org/presentationml/2006/main">
   <p:cSld>
     <p:spTree>
       <p:nvGrpSpPr>
@@ -833,7 +627,7 @@
         <p:nvSpPr>
           <p:cNvPr id="2" name="Slide Image Placeholder 1"/>
           <p:cNvSpPr>
-            <a:spLocks noGrp="1"/>
+            <a:spLocks noGrp="1" noRot="1" noChangeAspect="1"/>
           </p:cNvSpPr>
           <p:nvPr>
             <p:ph type="sldImg" idx="2"/>
@@ -848,7 +642,7 @@
             <a:spLocks noGrp="1"/>
           </p:cNvSpPr>
           <p:nvPr>
-            <p:ph type="body" idx="3" sz="quarter"/>
+            <p:ph type="body" sz="quarter" idx="3"/>
           </p:nvPr>
         </p:nvSpPr>
         <p:spPr/>
@@ -869,7 +663,7 @@
             <a:spLocks noGrp="1"/>
           </p:cNvSpPr>
           <p:nvPr>
-            <p:ph type="sldNum" idx="5" sz="quarter"/>
+            <p:ph type="sldNum" sz="quarter" idx="5"/>
           </p:nvPr>
         </p:nvSpPr>
         <p:spPr/>
@@ -920,10 +714,9 @@
           <a:lstStyle/>
           <a:p>
             <a:r>
-              <a:rPr lang="en-US" smtClean="0"/>
+              <a:rPr lang="en-US"/>
               <a:t>Click to edit Master title style</a:t>
             </a:r>
-            <a:endParaRPr lang="en-US"/>
           </a:p>
         </p:txBody>
       </p:sp>
@@ -1039,10 +832,9 @@
           </a:lstStyle>
           <a:p>
             <a:r>
-              <a:rPr lang="en-US" smtClean="0"/>
+              <a:rPr lang="en-US"/>
               <a:t>Click to edit Master subtitle style</a:t>
             </a:r>
-            <a:endParaRPr lang="en-US"/>
           </a:p>
         </p:txBody>
       </p:sp>
@@ -1063,7 +855,7 @@
           <a:p>
             <a:fld id="{5BCAD085-E8A6-8845-BD4E-CB4CCA059FC4}" type="datetimeFigureOut">
               <a:rPr lang="en-US" smtClean="0"/>
-              <a:t>1/27/13</a:t>
+              <a:t>7/7/2026</a:t>
             </a:fld>
             <a:endParaRPr lang="en-US"/>
           </a:p>
@@ -1105,7 +897,7 @@
           <a:p>
             <a:fld id="{C1FF6DA9-008F-8B48-92A6-B652298478BF}" type="slidenum">
               <a:rPr lang="en-US" smtClean="0"/>
-              <a:t>‹#›</a:t>
+              <a:t>‹nº›</a:t>
             </a:fld>
             <a:endParaRPr lang="en-US"/>
           </a:p>
@@ -1157,10 +949,9 @@
           <a:lstStyle/>
           <a:p>
             <a:r>
-              <a:rPr lang="en-US" smtClean="0"/>
+              <a:rPr lang="en-US"/>
               <a:t>Click to edit Master title style</a:t>
             </a:r>
-            <a:endParaRPr lang="en-US"/>
           </a:p>
         </p:txBody>
       </p:sp>
@@ -1181,38 +972,37 @@
           <a:p>
             <a:pPr lvl="0"/>
             <a:r>
-              <a:rPr lang="en-US" smtClean="0"/>
+              <a:rPr lang="en-US"/>
               <a:t>Click to edit Master text styles</a:t>
             </a:r>
           </a:p>
           <a:p>
             <a:pPr lvl="1"/>
             <a:r>
-              <a:rPr lang="en-US" smtClean="0"/>
+              <a:rPr lang="en-US"/>
               <a:t>Second level</a:t>
             </a:r>
           </a:p>
           <a:p>
             <a:pPr lvl="2"/>
             <a:r>
-              <a:rPr lang="en-US" smtClean="0"/>
+              <a:rPr lang="en-US"/>
               <a:t>Third level</a:t>
             </a:r>
           </a:p>
           <a:p>
             <a:pPr lvl="3"/>
             <a:r>
-              <a:rPr lang="en-US" smtClean="0"/>
+              <a:rPr lang="en-US"/>
               <a:t>Fourth level</a:t>
             </a:r>
           </a:p>
           <a:p>
             <a:pPr lvl="4"/>
             <a:r>
-              <a:rPr lang="en-US" smtClean="0"/>
+              <a:rPr lang="en-US"/>
               <a:t>Fifth level</a:t>
             </a:r>
-            <a:endParaRPr lang="en-US"/>
           </a:p>
         </p:txBody>
       </p:sp>
@@ -1233,7 +1023,7 @@
           <a:p>
             <a:fld id="{5BCAD085-E8A6-8845-BD4E-CB4CCA059FC4}" type="datetimeFigureOut">
               <a:rPr lang="en-US" smtClean="0"/>
-              <a:t>1/27/13</a:t>
+              <a:t>7/7/2026</a:t>
             </a:fld>
             <a:endParaRPr lang="en-US"/>
           </a:p>
@@ -1275,7 +1065,7 @@
           <a:p>
             <a:fld id="{C1FF6DA9-008F-8B48-92A6-B652298478BF}" type="slidenum">
               <a:rPr lang="en-US" smtClean="0"/>
-              <a:t>‹#›</a:t>
+              <a:t>‹nº›</a:t>
             </a:fld>
             <a:endParaRPr lang="en-US"/>
           </a:p>
@@ -1332,10 +1122,9 @@
           <a:lstStyle/>
           <a:p>
             <a:r>
-              <a:rPr lang="en-US" smtClean="0"/>
+              <a:rPr lang="en-US"/>
               <a:t>Click to edit Master title style</a:t>
             </a:r>
-            <a:endParaRPr lang="en-US"/>
           </a:p>
         </p:txBody>
       </p:sp>
@@ -1361,38 +1150,37 @@
           <a:p>
             <a:pPr lvl="0"/>
             <a:r>
-              <a:rPr lang="en-US" smtClean="0"/>
+              <a:rPr lang="en-US"/>
               <a:t>Click to edit Master text styles</a:t>
             </a:r>
           </a:p>
           <a:p>
             <a:pPr lvl="1"/>
             <a:r>
-              <a:rPr lang="en-US" smtClean="0"/>
+              <a:rPr lang="en-US"/>
               <a:t>Second level</a:t>
             </a:r>
           </a:p>
           <a:p>
             <a:pPr lvl="2"/>
             <a:r>
-              <a:rPr lang="en-US" smtClean="0"/>
+              <a:rPr lang="en-US"/>
               <a:t>Third level</a:t>
             </a:r>
           </a:p>
           <a:p>
             <a:pPr lvl="3"/>
             <a:r>
-              <a:rPr lang="en-US" smtClean="0"/>
+              <a:rPr lang="en-US"/>
               <a:t>Fourth level</a:t>
             </a:r>
           </a:p>
           <a:p>
             <a:pPr lvl="4"/>
             <a:r>
-              <a:rPr lang="en-US" smtClean="0"/>
+              <a:rPr lang="en-US"/>
               <a:t>Fifth level</a:t>
             </a:r>
-            <a:endParaRPr lang="en-US"/>
           </a:p>
         </p:txBody>
       </p:sp>
@@ -1413,7 +1201,7 @@
           <a:p>
             <a:fld id="{5BCAD085-E8A6-8845-BD4E-CB4CCA059FC4}" type="datetimeFigureOut">
               <a:rPr lang="en-US" smtClean="0"/>
-              <a:t>1/27/13</a:t>
+              <a:t>7/7/2026</a:t>
             </a:fld>
             <a:endParaRPr lang="en-US"/>
           </a:p>
@@ -1455,7 +1243,7 @@
           <a:p>
             <a:fld id="{C1FF6DA9-008F-8B48-92A6-B652298478BF}" type="slidenum">
               <a:rPr lang="en-US" smtClean="0"/>
-              <a:t>‹#›</a:t>
+              <a:t>‹nº›</a:t>
             </a:fld>
             <a:endParaRPr lang="en-US"/>
           </a:p>
@@ -1507,10 +1295,9 @@
           <a:lstStyle/>
           <a:p>
             <a:r>
-              <a:rPr lang="en-US" smtClean="0"/>
+              <a:rPr lang="en-US"/>
               <a:t>Click to edit Master title style</a:t>
             </a:r>
-            <a:endParaRPr lang="en-US"/>
           </a:p>
         </p:txBody>
       </p:sp>
@@ -1531,38 +1318,37 @@
           <a:p>
             <a:pPr lvl="0"/>
             <a:r>
-              <a:rPr lang="en-US" smtClean="0"/>
+              <a:rPr lang="en-US"/>
               <a:t>Click to edit Master text styles</a:t>
             </a:r>
           </a:p>
           <a:p>
             <a:pPr lvl="1"/>
             <a:r>
-              <a:rPr lang="en-US" smtClean="0"/>
+              <a:rPr lang="en-US"/>
               <a:t>Second level</a:t>
             </a:r>
           </a:p>
           <a:p>
             <a:pPr lvl="2"/>
             <a:r>
-              <a:rPr lang="en-US" smtClean="0"/>
+              <a:rPr lang="en-US"/>
               <a:t>Third level</a:t>
             </a:r>
           </a:p>
           <a:p>
             <a:pPr lvl="3"/>
             <a:r>
-              <a:rPr lang="en-US" smtClean="0"/>
+              <a:rPr lang="en-US"/>
               <a:t>Fourth level</a:t>
             </a:r>
           </a:p>
           <a:p>
             <a:pPr lvl="4"/>
             <a:r>
-              <a:rPr lang="en-US" smtClean="0"/>
+              <a:rPr lang="en-US"/>
               <a:t>Fifth level</a:t>
             </a:r>
-            <a:endParaRPr lang="en-US"/>
           </a:p>
         </p:txBody>
       </p:sp>
@@ -1583,7 +1369,7 @@
           <a:p>
             <a:fld id="{5BCAD085-E8A6-8845-BD4E-CB4CCA059FC4}" type="datetimeFigureOut">
               <a:rPr lang="en-US" smtClean="0"/>
-              <a:t>1/27/13</a:t>
+              <a:t>7/7/2026</a:t>
             </a:fld>
             <a:endParaRPr lang="en-US"/>
           </a:p>
@@ -1625,7 +1411,7 @@
           <a:p>
             <a:fld id="{C1FF6DA9-008F-8B48-92A6-B652298478BF}" type="slidenum">
               <a:rPr lang="en-US" smtClean="0"/>
-              <a:t>‹#›</a:t>
+              <a:t>‹nº›</a:t>
             </a:fld>
             <a:endParaRPr lang="en-US"/>
           </a:p>
@@ -1686,10 +1472,9 @@
           </a:lstStyle>
           <a:p>
             <a:r>
-              <a:rPr lang="en-US" smtClean="0"/>
+              <a:rPr lang="en-US"/>
               <a:t>Click to edit Master title style</a:t>
             </a:r>
-            <a:endParaRPr lang="en-US"/>
           </a:p>
         </p:txBody>
       </p:sp>
@@ -1806,7 +1591,7 @@
           <a:p>
             <a:pPr lvl="0"/>
             <a:r>
-              <a:rPr lang="en-US" smtClean="0"/>
+              <a:rPr lang="en-US"/>
               <a:t>Click to edit Master text styles</a:t>
             </a:r>
           </a:p>
@@ -1829,7 +1614,7 @@
           <a:p>
             <a:fld id="{5BCAD085-E8A6-8845-BD4E-CB4CCA059FC4}" type="datetimeFigureOut">
               <a:rPr lang="en-US" smtClean="0"/>
-              <a:t>1/27/13</a:t>
+              <a:t>7/7/2026</a:t>
             </a:fld>
             <a:endParaRPr lang="en-US"/>
           </a:p>
@@ -1871,7 +1656,7 @@
           <a:p>
             <a:fld id="{C1FF6DA9-008F-8B48-92A6-B652298478BF}" type="slidenum">
               <a:rPr lang="en-US" smtClean="0"/>
-              <a:t>‹#›</a:t>
+              <a:t>‹nº›</a:t>
             </a:fld>
             <a:endParaRPr lang="en-US"/>
           </a:p>
@@ -1923,10 +1708,9 @@
           <a:lstStyle/>
           <a:p>
             <a:r>
-              <a:rPr lang="en-US" smtClean="0"/>
+              <a:rPr lang="en-US"/>
               <a:t>Click to edit Master title style</a:t>
             </a:r>
-            <a:endParaRPr lang="en-US"/>
           </a:p>
         </p:txBody>
       </p:sp>
@@ -1980,38 +1764,37 @@
           <a:p>
             <a:pPr lvl="0"/>
             <a:r>
-              <a:rPr lang="en-US" smtClean="0"/>
+              <a:rPr lang="en-US"/>
               <a:t>Click to edit Master text styles</a:t>
             </a:r>
           </a:p>
           <a:p>
             <a:pPr lvl="1"/>
             <a:r>
-              <a:rPr lang="en-US" smtClean="0"/>
+              <a:rPr lang="en-US"/>
               <a:t>Second level</a:t>
             </a:r>
           </a:p>
           <a:p>
             <a:pPr lvl="2"/>
             <a:r>
-              <a:rPr lang="en-US" smtClean="0"/>
+              <a:rPr lang="en-US"/>
               <a:t>Third level</a:t>
             </a:r>
           </a:p>
           <a:p>
             <a:pPr lvl="3"/>
             <a:r>
-              <a:rPr lang="en-US" smtClean="0"/>
+              <a:rPr lang="en-US"/>
               <a:t>Fourth level</a:t>
             </a:r>
           </a:p>
           <a:p>
             <a:pPr lvl="4"/>
             <a:r>
-              <a:rPr lang="en-US" smtClean="0"/>
+              <a:rPr lang="en-US"/>
               <a:t>Fifth level</a:t>
             </a:r>
-            <a:endParaRPr lang="en-US"/>
           </a:p>
         </p:txBody>
       </p:sp>
@@ -2065,38 +1848,37 @@
           <a:p>
             <a:pPr lvl="0"/>
             <a:r>
-              <a:rPr lang="en-US" smtClean="0"/>
+              <a:rPr lang="en-US"/>
               <a:t>Click to edit Master text styles</a:t>
             </a:r>
           </a:p>
           <a:p>
             <a:pPr lvl="1"/>
             <a:r>
-              <a:rPr lang="en-US" smtClean="0"/>
+              <a:rPr lang="en-US"/>
               <a:t>Second level</a:t>
             </a:r>
           </a:p>
           <a:p>
             <a:pPr lvl="2"/>
             <a:r>
-              <a:rPr lang="en-US" smtClean="0"/>
+              <a:rPr lang="en-US"/>
               <a:t>Third level</a:t>
             </a:r>
           </a:p>
           <a:p>
             <a:pPr lvl="3"/>
             <a:r>
-              <a:rPr lang="en-US" smtClean="0"/>
+              <a:rPr lang="en-US"/>
               <a:t>Fourth level</a:t>
             </a:r>
           </a:p>
           <a:p>
             <a:pPr lvl="4"/>
             <a:r>
-              <a:rPr lang="en-US" smtClean="0"/>
+              <a:rPr lang="en-US"/>
               <a:t>Fifth level</a:t>
             </a:r>
-            <a:endParaRPr lang="en-US"/>
           </a:p>
         </p:txBody>
       </p:sp>
@@ -2117,7 +1899,7 @@
           <a:p>
             <a:fld id="{5BCAD085-E8A6-8845-BD4E-CB4CCA059FC4}" type="datetimeFigureOut">
               <a:rPr lang="en-US" smtClean="0"/>
-              <a:t>1/27/13</a:t>
+              <a:t>7/7/2026</a:t>
             </a:fld>
             <a:endParaRPr lang="en-US"/>
           </a:p>
@@ -2159,7 +1941,7 @@
           <a:p>
             <a:fld id="{C1FF6DA9-008F-8B48-92A6-B652298478BF}" type="slidenum">
               <a:rPr lang="en-US" smtClean="0"/>
-              <a:t>‹#›</a:t>
+              <a:t>‹nº›</a:t>
             </a:fld>
             <a:endParaRPr lang="en-US"/>
           </a:p>
@@ -2215,10 +1997,9 @@
           </a:lstStyle>
           <a:p>
             <a:r>
-              <a:rPr lang="en-US" smtClean="0"/>
+              <a:rPr lang="en-US"/>
               <a:t>Click to edit Master title style</a:t>
             </a:r>
-            <a:endParaRPr lang="en-US"/>
           </a:p>
         </p:txBody>
       </p:sp>
@@ -2281,7 +2062,7 @@
           <a:p>
             <a:pPr lvl="0"/>
             <a:r>
-              <a:rPr lang="en-US" smtClean="0"/>
+              <a:rPr lang="en-US"/>
               <a:t>Click to edit Master text styles</a:t>
             </a:r>
           </a:p>
@@ -2337,38 +2118,37 @@
           <a:p>
             <a:pPr lvl="0"/>
             <a:r>
-              <a:rPr lang="en-US" smtClean="0"/>
+              <a:rPr lang="en-US"/>
               <a:t>Click to edit Master text styles</a:t>
             </a:r>
           </a:p>
           <a:p>
             <a:pPr lvl="1"/>
             <a:r>
-              <a:rPr lang="en-US" smtClean="0"/>
+              <a:rPr lang="en-US"/>
               <a:t>Second level</a:t>
             </a:r>
           </a:p>
           <a:p>
             <a:pPr lvl="2"/>
             <a:r>
-              <a:rPr lang="en-US" smtClean="0"/>
+              <a:rPr lang="en-US"/>
               <a:t>Third level</a:t>
             </a:r>
           </a:p>
           <a:p>
             <a:pPr lvl="3"/>
             <a:r>
-              <a:rPr lang="en-US" smtClean="0"/>
+              <a:rPr lang="en-US"/>
               <a:t>Fourth level</a:t>
             </a:r>
           </a:p>
           <a:p>
             <a:pPr lvl="4"/>
             <a:r>
-              <a:rPr lang="en-US" smtClean="0"/>
+              <a:rPr lang="en-US"/>
               <a:t>Fifth level</a:t>
             </a:r>
-            <a:endParaRPr lang="en-US"/>
           </a:p>
         </p:txBody>
       </p:sp>
@@ -2431,7 +2211,7 @@
           <a:p>
             <a:pPr lvl="0"/>
             <a:r>
-              <a:rPr lang="en-US" smtClean="0"/>
+              <a:rPr lang="en-US"/>
               <a:t>Click to edit Master text styles</a:t>
             </a:r>
           </a:p>
@@ -2487,38 +2267,37 @@
           <a:p>
             <a:pPr lvl="0"/>
             <a:r>
-              <a:rPr lang="en-US" smtClean="0"/>
+              <a:rPr lang="en-US"/>
               <a:t>Click to edit Master text styles</a:t>
             </a:r>
           </a:p>
           <a:p>
             <a:pPr lvl="1"/>
             <a:r>
-              <a:rPr lang="en-US" smtClean="0"/>
+              <a:rPr lang="en-US"/>
               <a:t>Second level</a:t>
             </a:r>
           </a:p>
           <a:p>
             <a:pPr lvl="2"/>
             <a:r>
-              <a:rPr lang="en-US" smtClean="0"/>
+              <a:rPr lang="en-US"/>
               <a:t>Third level</a:t>
             </a:r>
           </a:p>
           <a:p>
             <a:pPr lvl="3"/>
             <a:r>
-              <a:rPr lang="en-US" smtClean="0"/>
+              <a:rPr lang="en-US"/>
               <a:t>Fourth level</a:t>
             </a:r>
           </a:p>
           <a:p>
             <a:pPr lvl="4"/>
             <a:r>
-              <a:rPr lang="en-US" smtClean="0"/>
+              <a:rPr lang="en-US"/>
               <a:t>Fifth level</a:t>
             </a:r>
-            <a:endParaRPr lang="en-US"/>
           </a:p>
         </p:txBody>
       </p:sp>
@@ -2539,7 +2318,7 @@
           <a:p>
             <a:fld id="{5BCAD085-E8A6-8845-BD4E-CB4CCA059FC4}" type="datetimeFigureOut">
               <a:rPr lang="en-US" smtClean="0"/>
-              <a:t>1/27/13</a:t>
+              <a:t>7/7/2026</a:t>
             </a:fld>
             <a:endParaRPr lang="en-US"/>
           </a:p>
@@ -2581,7 +2360,7 @@
           <a:p>
             <a:fld id="{C1FF6DA9-008F-8B48-92A6-B652298478BF}" type="slidenum">
               <a:rPr lang="en-US" smtClean="0"/>
-              <a:t>‹#›</a:t>
+              <a:t>‹nº›</a:t>
             </a:fld>
             <a:endParaRPr lang="en-US"/>
           </a:p>
@@ -2633,10 +2412,9 @@
           <a:lstStyle/>
           <a:p>
             <a:r>
-              <a:rPr lang="en-US" smtClean="0"/>
+              <a:rPr lang="en-US"/>
               <a:t>Click to edit Master title style</a:t>
             </a:r>
-            <a:endParaRPr lang="en-US"/>
           </a:p>
         </p:txBody>
       </p:sp>
@@ -2657,7 +2435,7 @@
           <a:p>
             <a:fld id="{5BCAD085-E8A6-8845-BD4E-CB4CCA059FC4}" type="datetimeFigureOut">
               <a:rPr lang="en-US" smtClean="0"/>
-              <a:t>1/27/13</a:t>
+              <a:t>7/7/2026</a:t>
             </a:fld>
             <a:endParaRPr lang="en-US"/>
           </a:p>
@@ -2699,7 +2477,7 @@
           <a:p>
             <a:fld id="{C1FF6DA9-008F-8B48-92A6-B652298478BF}" type="slidenum">
               <a:rPr lang="en-US" smtClean="0"/>
-              <a:t>‹#›</a:t>
+              <a:t>‹nº›</a:t>
             </a:fld>
             <a:endParaRPr lang="en-US"/>
           </a:p>
@@ -2752,7 +2530,7 @@
           <a:p>
             <a:fld id="{5BCAD085-E8A6-8845-BD4E-CB4CCA059FC4}" type="datetimeFigureOut">
               <a:rPr lang="en-US" smtClean="0"/>
-              <a:t>1/27/13</a:t>
+              <a:t>7/7/2026</a:t>
             </a:fld>
             <a:endParaRPr lang="en-US"/>
           </a:p>
@@ -2794,7 +2572,7 @@
           <a:p>
             <a:fld id="{C1FF6DA9-008F-8B48-92A6-B652298478BF}" type="slidenum">
               <a:rPr lang="en-US" smtClean="0"/>
-              <a:t>‹#›</a:t>
+              <a:t>‹nº›</a:t>
             </a:fld>
             <a:endParaRPr lang="en-US"/>
           </a:p>
@@ -2855,10 +2633,9 @@
           </a:lstStyle>
           <a:p>
             <a:r>
-              <a:rPr lang="en-US" smtClean="0"/>
+              <a:rPr lang="en-US"/>
               <a:t>Click to edit Master title style</a:t>
             </a:r>
-            <a:endParaRPr lang="en-US"/>
           </a:p>
         </p:txBody>
       </p:sp>
@@ -2912,38 +2689,37 @@
           <a:p>
             <a:pPr lvl="0"/>
             <a:r>
-              <a:rPr lang="en-US" smtClean="0"/>
+              <a:rPr lang="en-US"/>
               <a:t>Click to edit Master text styles</a:t>
             </a:r>
           </a:p>
           <a:p>
             <a:pPr lvl="1"/>
             <a:r>
-              <a:rPr lang="en-US" smtClean="0"/>
+              <a:rPr lang="en-US"/>
               <a:t>Second level</a:t>
             </a:r>
           </a:p>
           <a:p>
             <a:pPr lvl="2"/>
             <a:r>
-              <a:rPr lang="en-US" smtClean="0"/>
+              <a:rPr lang="en-US"/>
               <a:t>Third level</a:t>
             </a:r>
           </a:p>
           <a:p>
             <a:pPr lvl="3"/>
             <a:r>
-              <a:rPr lang="en-US" smtClean="0"/>
+              <a:rPr lang="en-US"/>
               <a:t>Fourth level</a:t>
             </a:r>
           </a:p>
           <a:p>
             <a:pPr lvl="4"/>
             <a:r>
-              <a:rPr lang="en-US" smtClean="0"/>
+              <a:rPr lang="en-US"/>
               <a:t>Fifth level</a:t>
             </a:r>
-            <a:endParaRPr lang="en-US"/>
           </a:p>
         </p:txBody>
       </p:sp>
@@ -3006,7 +2782,7 @@
           <a:p>
             <a:pPr lvl="0"/>
             <a:r>
-              <a:rPr lang="en-US" smtClean="0"/>
+              <a:rPr lang="en-US"/>
               <a:t>Click to edit Master text styles</a:t>
             </a:r>
           </a:p>
@@ -3029,7 +2805,7 @@
           <a:p>
             <a:fld id="{5BCAD085-E8A6-8845-BD4E-CB4CCA059FC4}" type="datetimeFigureOut">
               <a:rPr lang="en-US" smtClean="0"/>
-              <a:t>1/27/13</a:t>
+              <a:t>7/7/2026</a:t>
             </a:fld>
             <a:endParaRPr lang="en-US"/>
           </a:p>
@@ -3071,7 +2847,7 @@
           <a:p>
             <a:fld id="{C1FF6DA9-008F-8B48-92A6-B652298478BF}" type="slidenum">
               <a:rPr lang="en-US" smtClean="0"/>
-              <a:t>‹#›</a:t>
+              <a:t>‹nº›</a:t>
             </a:fld>
             <a:endParaRPr lang="en-US"/>
           </a:p>
@@ -3132,10 +2908,9 @@
           </a:lstStyle>
           <a:p>
             <a:r>
-              <a:rPr lang="en-US" smtClean="0"/>
+              <a:rPr lang="en-US"/>
               <a:t>Click to edit Master title style</a:t>
             </a:r>
-            <a:endParaRPr lang="en-US"/>
           </a:p>
         </p:txBody>
       </p:sp>
@@ -3259,7 +3034,7 @@
           <a:p>
             <a:pPr lvl="0"/>
             <a:r>
-              <a:rPr lang="en-US" smtClean="0"/>
+              <a:rPr lang="en-US"/>
               <a:t>Click to edit Master text styles</a:t>
             </a:r>
           </a:p>
@@ -3282,7 +3057,7 @@
           <a:p>
             <a:fld id="{5BCAD085-E8A6-8845-BD4E-CB4CCA059FC4}" type="datetimeFigureOut">
               <a:rPr lang="en-US" smtClean="0"/>
-              <a:t>1/27/13</a:t>
+              <a:t>7/7/2026</a:t>
             </a:fld>
             <a:endParaRPr lang="en-US"/>
           </a:p>
@@ -3324,7 +3099,7 @@
           <a:p>
             <a:fld id="{C1FF6DA9-008F-8B48-92A6-B652298478BF}" type="slidenum">
               <a:rPr lang="en-US" smtClean="0"/>
-              <a:t>‹#›</a:t>
+              <a:t>‹nº›</a:t>
             </a:fld>
             <a:endParaRPr lang="en-US"/>
           </a:p>
@@ -3391,10 +3166,9 @@
           <a:lstStyle/>
           <a:p>
             <a:r>
-              <a:rPr lang="en-US" smtClean="0"/>
+              <a:rPr lang="en-US"/>
               <a:t>Click to edit Master title style</a:t>
             </a:r>
-            <a:endParaRPr lang="en-US"/>
           </a:p>
         </p:txBody>
       </p:sp>
@@ -3425,38 +3199,37 @@
           <a:p>
             <a:pPr lvl="0"/>
             <a:r>
-              <a:rPr lang="en-US" smtClean="0"/>
+              <a:rPr lang="en-US"/>
               <a:t>Click to edit Master text styles</a:t>
             </a:r>
           </a:p>
           <a:p>
             <a:pPr lvl="1"/>
             <a:r>
-              <a:rPr lang="en-US" smtClean="0"/>
+              <a:rPr lang="en-US"/>
               <a:t>Second level</a:t>
             </a:r>
           </a:p>
           <a:p>
             <a:pPr lvl="2"/>
             <a:r>
-              <a:rPr lang="en-US" smtClean="0"/>
+              <a:rPr lang="en-US"/>
               <a:t>Third level</a:t>
             </a:r>
           </a:p>
           <a:p>
             <a:pPr lvl="3"/>
             <a:r>
-              <a:rPr lang="en-US" smtClean="0"/>
+              <a:rPr lang="en-US"/>
               <a:t>Fourth level</a:t>
             </a:r>
           </a:p>
           <a:p>
             <a:pPr lvl="4"/>
             <a:r>
-              <a:rPr lang="en-US" smtClean="0"/>
+              <a:rPr lang="en-US"/>
               <a:t>Fifth level</a:t>
             </a:r>
-            <a:endParaRPr lang="en-US"/>
           </a:p>
         </p:txBody>
       </p:sp>
@@ -3495,7 +3268,7 @@
           <a:p>
             <a:fld id="{5BCAD085-E8A6-8845-BD4E-CB4CCA059FC4}" type="datetimeFigureOut">
               <a:rPr lang="en-US" smtClean="0"/>
-              <a:t>1/27/13</a:t>
+              <a:t>7/7/2026</a:t>
             </a:fld>
             <a:endParaRPr lang="en-US"/>
           </a:p>
@@ -3573,7 +3346,7 @@
           <a:p>
             <a:fld id="{C1FF6DA9-008F-8B48-92A6-B652298478BF}" type="slidenum">
               <a:rPr lang="en-US" smtClean="0"/>
-              <a:t>‹#›</a:t>
+              <a:t>‹nº›</a:t>
             </a:fld>
             <a:endParaRPr lang="en-US"/>
           </a:p>
@@ -3854,7 +3627,7 @@
 </file>
 
 <file path=ppt/slides/slide1.xml><?xml version="1.0" encoding="utf-8"?>
-<p:sld xmlns:a="http://schemas.openxmlformats.org/drawingml/2006/main" xmlns:p="http://schemas.openxmlformats.org/presentationml/2006/main" xmlns:r="http://schemas.openxmlformats.org/officeDocument/2006/relationships">
+<p:sld xmlns:a="http://schemas.openxmlformats.org/drawingml/2006/main" xmlns:r="http://schemas.openxmlformats.org/officeDocument/2006/relationships" xmlns:p="http://schemas.openxmlformats.org/presentationml/2006/main">
   <p:cSld>
     <p:spTree>
       <p:nvGrpSpPr>
@@ -3862,7 +3635,14 @@
         <p:cNvGrpSpPr/>
         <p:nvPr/>
       </p:nvGrpSpPr>
-      <p:grpSpPr/>
+      <p:grpSpPr>
+        <a:xfrm>
+          <a:off x="0" y="0"/>
+          <a:ext cx="0" cy="0"/>
+          <a:chOff x="0" y="0"/>
+          <a:chExt cx="0" cy="0"/>
+        </a:xfrm>
+      </p:grpSpPr>
       <p:sp>
         <p:nvSpPr>
           <p:cNvPr id="2" name="Rectangle 1"/>
@@ -3904,6 +3684,7 @@
           <a:lstStyle/>
           <a:p>
             <a:pPr algn="ctr"/>
+            <a:endParaRPr/>
           </a:p>
         </p:txBody>
       </p:sp>
@@ -3948,6 +3729,7 @@
           <a:lstStyle/>
           <a:p>
             <a:pPr algn="ctr"/>
+            <a:endParaRPr/>
           </a:p>
         </p:txBody>
       </p:sp>
@@ -3992,6 +3774,7 @@
           <a:lstStyle/>
           <a:p>
             <a:pPr algn="ctr"/>
+            <a:endParaRPr/>
           </a:p>
         </p:txBody>
       </p:sp>
@@ -4036,6 +3819,7 @@
           <a:lstStyle/>
           <a:p>
             <a:pPr algn="ctr"/>
+            <a:endParaRPr/>
           </a:p>
         </p:txBody>
       </p:sp>
@@ -4080,6 +3864,7 @@
           <a:lstStyle/>
           <a:p>
             <a:pPr algn="ctr"/>
+            <a:endParaRPr/>
           </a:p>
         </p:txBody>
       </p:sp>
@@ -4092,7 +3877,7 @@
           <p:nvPr/>
         </p:nvPicPr>
         <p:blipFill>
-          <a:blip r:embed="rId2"/>
+          <a:blip r:embed="rId3"/>
           <a:stretch>
             <a:fillRect/>
           </a:stretch>
@@ -4124,7 +3909,7 @@
           <a:noFill/>
         </p:spPr>
         <p:txBody>
-          <a:bodyPr wrap="square" anchor="t" lIns="0" rIns="0" tIns="0" bIns="0">
+          <a:bodyPr wrap="square" lIns="0" tIns="0" rIns="0" bIns="0" anchor="t">
             <a:spAutoFit/>
           </a:bodyPr>
           <a:lstStyle/>
@@ -4193,6 +3978,7 @@
           <a:lstStyle/>
           <a:p>
             <a:pPr algn="ctr"/>
+            <a:endParaRPr/>
           </a:p>
         </p:txBody>
       </p:sp>
@@ -4237,6 +4023,7 @@
           <a:lstStyle/>
           <a:p>
             <a:pPr algn="ctr"/>
+            <a:endParaRPr/>
           </a:p>
         </p:txBody>
       </p:sp>
@@ -4281,6 +4068,7 @@
           <a:lstStyle/>
           <a:p>
             <a:pPr algn="ctr"/>
+            <a:endParaRPr/>
           </a:p>
         </p:txBody>
       </p:sp>
@@ -4325,6 +4113,7 @@
           <a:lstStyle/>
           <a:p>
             <a:pPr algn="ctr"/>
+            <a:endParaRPr/>
           </a:p>
         </p:txBody>
       </p:sp>
@@ -4345,7 +4134,7 @@
           <a:noFill/>
         </p:spPr>
         <p:txBody>
-          <a:bodyPr wrap="square" anchor="t" lIns="0" rIns="0" tIns="0" bIns="0">
+          <a:bodyPr wrap="square" lIns="0" tIns="0" rIns="0" bIns="0" anchor="t">
             <a:spAutoFit/>
           </a:bodyPr>
           <a:lstStyle/>
@@ -4412,7 +4201,7 @@
           <a:noFill/>
         </p:spPr>
         <p:txBody>
-          <a:bodyPr wrap="square" anchor="t" lIns="0" rIns="0" tIns="0" bIns="0">
+          <a:bodyPr wrap="square" lIns="0" tIns="0" rIns="0" bIns="0" anchor="t">
             <a:spAutoFit/>
           </a:bodyPr>
           <a:lstStyle/>
@@ -4503,6 +4292,7 @@
           <a:lstStyle/>
           <a:p>
             <a:pPr algn="ctr"/>
+            <a:endParaRPr/>
           </a:p>
         </p:txBody>
       </p:sp>
@@ -4514,8 +4304,8 @@
         </p:nvSpPr>
         <p:spPr>
           <a:xfrm>
-            <a:off x="777240" y="6016752"/>
-            <a:ext cx="10607040" cy="822960"/>
+            <a:off x="777240" y="6330480"/>
+            <a:ext cx="10607040" cy="195503"/>
           </a:xfrm>
           <a:prstGeom prst="rect">
             <a:avLst/>
@@ -4523,7 +4313,7 @@
           <a:noFill/>
         </p:spPr>
         <p:txBody>
-          <a:bodyPr wrap="square" anchor="ctr" lIns="0" rIns="0" tIns="0" bIns="0">
+          <a:bodyPr wrap="square" lIns="0" tIns="0" rIns="0" bIns="0" anchor="ctr">
             <a:spAutoFit/>
           </a:bodyPr>
           <a:lstStyle/>
@@ -4540,15 +4330,107 @@
               </a:spcAft>
             </a:pPr>
             <a:r>
-              <a:rPr sz="1300" b="0" i="0">
+              <a:rPr sz="1300" b="0" i="0" dirty="0" err="1">
                 <a:solidFill>
                   <a:srgbClr val="48535E"/>
                 </a:solidFill>
                 <a:latin typeface="Arial"/>
               </a:rPr>
-              <a:t>Eixo temático: ____________     ·     Modalidade: Comunicação oral</a:t>
-            </a:r>
-          </a:p>
+              <a:t>Eixo</a:t>
+            </a:r>
+            <a:r>
+              <a:rPr sz="1300" b="0" i="0" dirty="0">
+                <a:solidFill>
+                  <a:srgbClr val="48535E"/>
+                </a:solidFill>
+                <a:latin typeface="Arial"/>
+              </a:rPr>
+              <a:t> </a:t>
+            </a:r>
+            <a:r>
+              <a:rPr sz="1300" b="0" i="0" dirty="0" err="1">
+                <a:solidFill>
+                  <a:srgbClr val="48535E"/>
+                </a:solidFill>
+                <a:latin typeface="Arial"/>
+              </a:rPr>
+              <a:t>temático</a:t>
+            </a:r>
+            <a:r>
+              <a:rPr sz="1300" b="0" i="0" dirty="0">
+                <a:solidFill>
+                  <a:srgbClr val="48535E"/>
+                </a:solidFill>
+                <a:latin typeface="Arial"/>
+              </a:rPr>
+              <a:t>: ____________     ·     </a:t>
+            </a:r>
+            <a:r>
+              <a:rPr sz="1300" b="0" i="0" dirty="0" err="1">
+                <a:solidFill>
+                  <a:srgbClr val="48535E"/>
+                </a:solidFill>
+                <a:latin typeface="Arial"/>
+              </a:rPr>
+              <a:t>Modalidade</a:t>
+            </a:r>
+            <a:r>
+              <a:rPr sz="1300" b="0" i="0" dirty="0">
+                <a:solidFill>
+                  <a:srgbClr val="48535E"/>
+                </a:solidFill>
+                <a:latin typeface="Arial"/>
+              </a:rPr>
+              <a:t>: </a:t>
+            </a:r>
+            <a:r>
+              <a:rPr sz="1300" b="0" i="0" dirty="0" err="1">
+                <a:solidFill>
+                  <a:srgbClr val="48535E"/>
+                </a:solidFill>
+                <a:latin typeface="Arial"/>
+              </a:rPr>
+              <a:t>Comunicação</a:t>
+            </a:r>
+            <a:r>
+              <a:rPr sz="1300" b="0" i="0" dirty="0">
+                <a:solidFill>
+                  <a:srgbClr val="48535E"/>
+                </a:solidFill>
+                <a:latin typeface="Arial"/>
+              </a:rPr>
+              <a:t> oral</a:t>
+            </a:r>
+          </a:p>
+        </p:txBody>
+      </p:sp>
+      <p:sp>
+        <p:nvSpPr>
+          <p:cNvPr id="18" name="CaixaDeTexto 17">
+            <a:extLst>
+              <a:ext uri="{FF2B5EF4-FFF2-40B4-BE49-F238E27FC236}">
+                <a16:creationId xmlns:a16="http://schemas.microsoft.com/office/drawing/2014/main" id="{F38A1911-34E6-AB31-D98D-8E30D8BF8214}"/>
+              </a:ext>
+            </a:extLst>
+          </p:cNvPr>
+          <p:cNvSpPr txBox="1"/>
+          <p:nvPr/>
+        </p:nvSpPr>
+        <p:spPr>
+          <a:xfrm>
+            <a:off x="9551111" y="3017028"/>
+            <a:ext cx="2174724" cy="2437462"/>
+          </a:xfrm>
+          <a:prstGeom prst="rect">
+            <a:avLst/>
+          </a:prstGeom>
+          <a:noFill/>
+        </p:spPr>
+        <p:txBody>
+          <a:bodyPr wrap="square">
+            <a:spAutoFit/>
+          </a:bodyPr>
+          <a:lstStyle/>
           <a:p>
             <a:pPr algn="l">
               <a:lnSpc>
@@ -4562,14 +4444,42 @@
               </a:spcAft>
             </a:pPr>
             <a:r>
-              <a:rPr sz="1200" b="0" i="1">
+              <a:rPr lang="pt-BR" b="0" i="1" dirty="0">
                 <a:solidFill>
                   <a:srgbClr val="788490"/>
                 </a:solidFill>
                 <a:latin typeface="Arial"/>
               </a:rPr>
-              <a:t>Tempo de apresentação: até 10 minutos (rigoroso) · sugestão: cerca de 2 minutos por slide.</a:t>
-            </a:r>
+              <a:t>Tempo de apresentação: até 10 minutos (rigoroso) · Sugestão: cerca de 2 minutos por slide.</a:t>
+            </a:r>
+          </a:p>
+          <a:p>
+            <a:pPr algn="l">
+              <a:lnSpc>
+                <a:spcPct val="105000"/>
+              </a:lnSpc>
+              <a:spcBef>
+                <a:spcPts val="0"/>
+              </a:spcBef>
+              <a:spcAft>
+                <a:spcPts val="300"/>
+              </a:spcAft>
+            </a:pPr>
+            <a:r>
+              <a:rPr lang="pt-BR" i="1" dirty="0">
+                <a:solidFill>
+                  <a:srgbClr val="FF0000"/>
+                </a:solidFill>
+                <a:latin typeface="Arial"/>
+              </a:rPr>
+              <a:t>Apague esta caixa de texto.</a:t>
+            </a:r>
+            <a:endParaRPr lang="pt-BR" b="0" i="1" dirty="0">
+              <a:solidFill>
+                <a:srgbClr val="FF0000"/>
+              </a:solidFill>
+              <a:latin typeface="Arial"/>
+            </a:endParaRPr>
           </a:p>
         </p:txBody>
       </p:sp>
@@ -4582,7 +4492,7 @@
 </file>
 
 <file path=ppt/slides/slide2.xml><?xml version="1.0" encoding="utf-8"?>
-<p:sld xmlns:a="http://schemas.openxmlformats.org/drawingml/2006/main" xmlns:p="http://schemas.openxmlformats.org/presentationml/2006/main" xmlns:r="http://schemas.openxmlformats.org/officeDocument/2006/relationships">
+<p:sld xmlns:a="http://schemas.openxmlformats.org/drawingml/2006/main" xmlns:r="http://schemas.openxmlformats.org/officeDocument/2006/relationships" xmlns:p="http://schemas.openxmlformats.org/presentationml/2006/main">
   <p:cSld>
     <p:spTree>
       <p:nvGrpSpPr>
@@ -4590,7 +4500,14 @@
         <p:cNvGrpSpPr/>
         <p:nvPr/>
       </p:nvGrpSpPr>
-      <p:grpSpPr/>
+      <p:grpSpPr>
+        <a:xfrm>
+          <a:off x="0" y="0"/>
+          <a:ext cx="0" cy="0"/>
+          <a:chOff x="0" y="0"/>
+          <a:chExt cx="0" cy="0"/>
+        </a:xfrm>
+      </p:grpSpPr>
       <p:sp>
         <p:nvSpPr>
           <p:cNvPr id="2" name="Rectangle 1"/>
@@ -4632,6 +4549,7 @@
           <a:lstStyle/>
           <a:p>
             <a:pPr algn="ctr"/>
+            <a:endParaRPr/>
           </a:p>
         </p:txBody>
       </p:sp>
@@ -4652,7 +4570,7 @@
           <a:noFill/>
         </p:spPr>
         <p:txBody>
-          <a:bodyPr wrap="square" anchor="ctr" lIns="0" rIns="0" tIns="0" bIns="0">
+          <a:bodyPr wrap="square" lIns="0" tIns="0" rIns="0" bIns="0" anchor="ctr">
             <a:spAutoFit/>
           </a:bodyPr>
           <a:lstStyle/>
@@ -4689,7 +4607,7 @@
           <p:nvPr/>
         </p:nvPicPr>
         <p:blipFill>
-          <a:blip r:embed="rId2"/>
+          <a:blip r:embed="rId3"/>
           <a:stretch>
             <a:fillRect/>
           </a:stretch>
@@ -4745,6 +4663,7 @@
           <a:lstStyle/>
           <a:p>
             <a:pPr algn="ctr"/>
+            <a:endParaRPr/>
           </a:p>
         </p:txBody>
       </p:sp>
@@ -4789,6 +4708,7 @@
           <a:lstStyle/>
           <a:p>
             <a:pPr algn="ctr"/>
+            <a:endParaRPr/>
           </a:p>
         </p:txBody>
       </p:sp>
@@ -4833,6 +4753,7 @@
           <a:lstStyle/>
           <a:p>
             <a:pPr algn="ctr"/>
+            <a:endParaRPr/>
           </a:p>
         </p:txBody>
       </p:sp>
@@ -4877,6 +4798,7 @@
           <a:lstStyle/>
           <a:p>
             <a:pPr algn="ctr"/>
+            <a:endParaRPr/>
           </a:p>
         </p:txBody>
       </p:sp>
@@ -4921,6 +4843,7 @@
           <a:lstStyle/>
           <a:p>
             <a:pPr algn="ctr"/>
+            <a:endParaRPr/>
           </a:p>
         </p:txBody>
       </p:sp>
@@ -4941,7 +4864,7 @@
           <a:noFill/>
         </p:spPr>
         <p:txBody>
-          <a:bodyPr wrap="square" anchor="t" lIns="0" rIns="0" tIns="0" bIns="0">
+          <a:bodyPr wrap="square" lIns="0" tIns="0" rIns="0" bIns="0" anchor="t">
             <a:spAutoFit/>
           </a:bodyPr>
           <a:lstStyle/>
@@ -5010,6 +4933,7 @@
           <a:lstStyle/>
           <a:p>
             <a:pPr algn="ctr"/>
+            <a:endParaRPr/>
           </a:p>
         </p:txBody>
       </p:sp>
@@ -5030,7 +4954,7 @@
           <a:noFill/>
         </p:spPr>
         <p:txBody>
-          <a:bodyPr wrap="square" anchor="t" lIns="0" rIns="0" tIns="0" bIns="0">
+          <a:bodyPr wrap="square" lIns="0" tIns="0" rIns="0" bIns="0" anchor="t">
             <a:spAutoFit/>
           </a:bodyPr>
           <a:lstStyle/>
@@ -5099,6 +5023,7 @@
           <a:lstStyle/>
           <a:p>
             <a:pPr algn="ctr"/>
+            <a:endParaRPr/>
           </a:p>
         </p:txBody>
       </p:sp>
@@ -5119,7 +5044,7 @@
           <a:noFill/>
         </p:spPr>
         <p:txBody>
-          <a:bodyPr wrap="square" anchor="t" lIns="0" rIns="0" tIns="0" bIns="0">
+          <a:bodyPr wrap="square" lIns="0" tIns="0" rIns="0" bIns="0" anchor="t">
             <a:spAutoFit/>
           </a:bodyPr>
           <a:lstStyle/>
@@ -5188,6 +5113,7 @@
           <a:lstStyle/>
           <a:p>
             <a:pPr algn="ctr"/>
+            <a:endParaRPr/>
           </a:p>
         </p:txBody>
       </p:sp>
@@ -5208,7 +5134,7 @@
           <a:noFill/>
         </p:spPr>
         <p:txBody>
-          <a:bodyPr wrap="square" anchor="ctr" lIns="0" rIns="0" tIns="0" bIns="0">
+          <a:bodyPr wrap="square" lIns="0" tIns="0" rIns="0" bIns="0" anchor="ctr">
             <a:spAutoFit/>
           </a:bodyPr>
           <a:lstStyle/>
@@ -5253,7 +5179,7 @@
           <a:noFill/>
         </p:spPr>
         <p:txBody>
-          <a:bodyPr wrap="square" anchor="ctr" lIns="0" rIns="0" tIns="0" bIns="0">
+          <a:bodyPr wrap="square" lIns="0" tIns="0" rIns="0" bIns="0" anchor="ctr">
             <a:spAutoFit/>
           </a:bodyPr>
           <a:lstStyle/>
@@ -5290,7 +5216,7 @@
 </file>
 
 <file path=ppt/slides/slide3.xml><?xml version="1.0" encoding="utf-8"?>
-<p:sld xmlns:a="http://schemas.openxmlformats.org/drawingml/2006/main" xmlns:p="http://schemas.openxmlformats.org/presentationml/2006/main" xmlns:r="http://schemas.openxmlformats.org/officeDocument/2006/relationships">
+<p:sld xmlns:a="http://schemas.openxmlformats.org/drawingml/2006/main" xmlns:r="http://schemas.openxmlformats.org/officeDocument/2006/relationships" xmlns:p="http://schemas.openxmlformats.org/presentationml/2006/main">
   <p:cSld>
     <p:spTree>
       <p:nvGrpSpPr>
@@ -5298,7 +5224,14 @@
         <p:cNvGrpSpPr/>
         <p:nvPr/>
       </p:nvGrpSpPr>
-      <p:grpSpPr/>
+      <p:grpSpPr>
+        <a:xfrm>
+          <a:off x="0" y="0"/>
+          <a:ext cx="0" cy="0"/>
+          <a:chOff x="0" y="0"/>
+          <a:chExt cx="0" cy="0"/>
+        </a:xfrm>
+      </p:grpSpPr>
       <p:sp>
         <p:nvSpPr>
           <p:cNvPr id="2" name="Rectangle 1"/>
@@ -5340,6 +5273,7 @@
           <a:lstStyle/>
           <a:p>
             <a:pPr algn="ctr"/>
+            <a:endParaRPr/>
           </a:p>
         </p:txBody>
       </p:sp>
@@ -5360,7 +5294,7 @@
           <a:noFill/>
         </p:spPr>
         <p:txBody>
-          <a:bodyPr wrap="square" anchor="ctr" lIns="0" rIns="0" tIns="0" bIns="0">
+          <a:bodyPr wrap="square" lIns="0" tIns="0" rIns="0" bIns="0" anchor="ctr">
             <a:spAutoFit/>
           </a:bodyPr>
           <a:lstStyle/>
@@ -5397,7 +5331,7 @@
           <p:nvPr/>
         </p:nvPicPr>
         <p:blipFill>
-          <a:blip r:embed="rId2"/>
+          <a:blip r:embed="rId3"/>
           <a:stretch>
             <a:fillRect/>
           </a:stretch>
@@ -5453,6 +5387,7 @@
           <a:lstStyle/>
           <a:p>
             <a:pPr algn="ctr"/>
+            <a:endParaRPr/>
           </a:p>
         </p:txBody>
       </p:sp>
@@ -5497,6 +5432,7 @@
           <a:lstStyle/>
           <a:p>
             <a:pPr algn="ctr"/>
+            <a:endParaRPr/>
           </a:p>
         </p:txBody>
       </p:sp>
@@ -5541,6 +5477,7 @@
           <a:lstStyle/>
           <a:p>
             <a:pPr algn="ctr"/>
+            <a:endParaRPr/>
           </a:p>
         </p:txBody>
       </p:sp>
@@ -5585,6 +5522,7 @@
           <a:lstStyle/>
           <a:p>
             <a:pPr algn="ctr"/>
+            <a:endParaRPr/>
           </a:p>
         </p:txBody>
       </p:sp>
@@ -5629,6 +5567,7 @@
           <a:lstStyle/>
           <a:p>
             <a:pPr algn="ctr"/>
+            <a:endParaRPr/>
           </a:p>
         </p:txBody>
       </p:sp>
@@ -5649,7 +5588,7 @@
           <a:noFill/>
         </p:spPr>
         <p:txBody>
-          <a:bodyPr wrap="square" anchor="t" lIns="0" rIns="0" tIns="0" bIns="0">
+          <a:bodyPr wrap="square" lIns="0" tIns="0" rIns="0" bIns="0" anchor="t">
             <a:spAutoFit/>
           </a:bodyPr>
           <a:lstStyle/>
@@ -5718,6 +5657,7 @@
           <a:lstStyle/>
           <a:p>
             <a:pPr algn="ctr"/>
+            <a:endParaRPr/>
           </a:p>
         </p:txBody>
       </p:sp>
@@ -5738,7 +5678,7 @@
           <a:noFill/>
         </p:spPr>
         <p:txBody>
-          <a:bodyPr wrap="square" anchor="t" lIns="0" rIns="0" tIns="0" bIns="0">
+          <a:bodyPr wrap="square" lIns="0" tIns="0" rIns="0" bIns="0" anchor="t">
             <a:spAutoFit/>
           </a:bodyPr>
           <a:lstStyle/>
@@ -5807,6 +5747,7 @@
           <a:lstStyle/>
           <a:p>
             <a:pPr algn="ctr"/>
+            <a:endParaRPr/>
           </a:p>
         </p:txBody>
       </p:sp>
@@ -5827,7 +5768,7 @@
           <a:noFill/>
         </p:spPr>
         <p:txBody>
-          <a:bodyPr wrap="square" anchor="t" lIns="0" rIns="0" tIns="0" bIns="0">
+          <a:bodyPr wrap="square" lIns="0" tIns="0" rIns="0" bIns="0" anchor="t">
             <a:spAutoFit/>
           </a:bodyPr>
           <a:lstStyle/>
@@ -5896,6 +5837,7 @@
           <a:lstStyle/>
           <a:p>
             <a:pPr algn="ctr"/>
+            <a:endParaRPr/>
           </a:p>
         </p:txBody>
       </p:sp>
@@ -5916,7 +5858,7 @@
           <a:noFill/>
         </p:spPr>
         <p:txBody>
-          <a:bodyPr wrap="square" anchor="t" lIns="0" rIns="0" tIns="0" bIns="0">
+          <a:bodyPr wrap="square" lIns="0" tIns="0" rIns="0" bIns="0" anchor="t">
             <a:spAutoFit/>
           </a:bodyPr>
           <a:lstStyle/>
@@ -5985,6 +5927,7 @@
           <a:lstStyle/>
           <a:p>
             <a:pPr algn="ctr"/>
+            <a:endParaRPr/>
           </a:p>
         </p:txBody>
       </p:sp>
@@ -6005,7 +5948,7 @@
           <a:noFill/>
         </p:spPr>
         <p:txBody>
-          <a:bodyPr wrap="square" anchor="ctr" lIns="0" rIns="0" tIns="0" bIns="0">
+          <a:bodyPr wrap="square" lIns="0" tIns="0" rIns="0" bIns="0" anchor="ctr">
             <a:spAutoFit/>
           </a:bodyPr>
           <a:lstStyle/>
@@ -6050,7 +5993,7 @@
           <a:noFill/>
         </p:spPr>
         <p:txBody>
-          <a:bodyPr wrap="square" anchor="ctr" lIns="0" rIns="0" tIns="0" bIns="0">
+          <a:bodyPr wrap="square" lIns="0" tIns="0" rIns="0" bIns="0" anchor="ctr">
             <a:spAutoFit/>
           </a:bodyPr>
           <a:lstStyle/>
@@ -6087,7 +6030,7 @@
 </file>
 
 <file path=ppt/slides/slide4.xml><?xml version="1.0" encoding="utf-8"?>
-<p:sld xmlns:a="http://schemas.openxmlformats.org/drawingml/2006/main" xmlns:p="http://schemas.openxmlformats.org/presentationml/2006/main" xmlns:r="http://schemas.openxmlformats.org/officeDocument/2006/relationships">
+<p:sld xmlns:a="http://schemas.openxmlformats.org/drawingml/2006/main" xmlns:r="http://schemas.openxmlformats.org/officeDocument/2006/relationships" xmlns:p="http://schemas.openxmlformats.org/presentationml/2006/main">
   <p:cSld>
     <p:spTree>
       <p:nvGrpSpPr>
@@ -6095,7 +6038,14 @@
         <p:cNvGrpSpPr/>
         <p:nvPr/>
       </p:nvGrpSpPr>
-      <p:grpSpPr/>
+      <p:grpSpPr>
+        <a:xfrm>
+          <a:off x="0" y="0"/>
+          <a:ext cx="0" cy="0"/>
+          <a:chOff x="0" y="0"/>
+          <a:chExt cx="0" cy="0"/>
+        </a:xfrm>
+      </p:grpSpPr>
       <p:sp>
         <p:nvSpPr>
           <p:cNvPr id="2" name="Rectangle 1"/>
@@ -6137,6 +6087,7 @@
           <a:lstStyle/>
           <a:p>
             <a:pPr algn="ctr"/>
+            <a:endParaRPr/>
           </a:p>
         </p:txBody>
       </p:sp>
@@ -6157,7 +6108,7 @@
           <a:noFill/>
         </p:spPr>
         <p:txBody>
-          <a:bodyPr wrap="square" anchor="ctr" lIns="0" rIns="0" tIns="0" bIns="0">
+          <a:bodyPr wrap="square" lIns="0" tIns="0" rIns="0" bIns="0" anchor="ctr">
             <a:spAutoFit/>
           </a:bodyPr>
           <a:lstStyle/>
@@ -6194,7 +6145,7 @@
           <p:nvPr/>
         </p:nvPicPr>
         <p:blipFill>
-          <a:blip r:embed="rId2"/>
+          <a:blip r:embed="rId3"/>
           <a:stretch>
             <a:fillRect/>
           </a:stretch>
@@ -6250,6 +6201,7 @@
           <a:lstStyle/>
           <a:p>
             <a:pPr algn="ctr"/>
+            <a:endParaRPr/>
           </a:p>
         </p:txBody>
       </p:sp>
@@ -6294,6 +6246,7 @@
           <a:lstStyle/>
           <a:p>
             <a:pPr algn="ctr"/>
+            <a:endParaRPr/>
           </a:p>
         </p:txBody>
       </p:sp>
@@ -6338,6 +6291,7 @@
           <a:lstStyle/>
           <a:p>
             <a:pPr algn="ctr"/>
+            <a:endParaRPr/>
           </a:p>
         </p:txBody>
       </p:sp>
@@ -6382,6 +6336,7 @@
           <a:lstStyle/>
           <a:p>
             <a:pPr algn="ctr"/>
+            <a:endParaRPr/>
           </a:p>
         </p:txBody>
       </p:sp>
@@ -6426,6 +6381,7 @@
           <a:lstStyle/>
           <a:p>
             <a:pPr algn="ctr"/>
+            <a:endParaRPr/>
           </a:p>
         </p:txBody>
       </p:sp>
@@ -6446,7 +6402,7 @@
           <a:noFill/>
         </p:spPr>
         <p:txBody>
-          <a:bodyPr wrap="square" anchor="t" lIns="0" rIns="0" tIns="0" bIns="0">
+          <a:bodyPr wrap="square" lIns="0" tIns="0" rIns="0" bIns="0" anchor="t">
             <a:spAutoFit/>
           </a:bodyPr>
           <a:lstStyle/>
@@ -6515,6 +6471,7 @@
           <a:lstStyle/>
           <a:p>
             <a:pPr algn="ctr"/>
+            <a:endParaRPr/>
           </a:p>
         </p:txBody>
       </p:sp>
@@ -6535,7 +6492,7 @@
           <a:noFill/>
         </p:spPr>
         <p:txBody>
-          <a:bodyPr wrap="square" anchor="t" lIns="0" rIns="0" tIns="0" bIns="0">
+          <a:bodyPr wrap="square" lIns="0" tIns="0" rIns="0" bIns="0" anchor="t">
             <a:spAutoFit/>
           </a:bodyPr>
           <a:lstStyle/>
@@ -6604,6 +6561,7 @@
           <a:lstStyle/>
           <a:p>
             <a:pPr algn="ctr"/>
+            <a:endParaRPr/>
           </a:p>
         </p:txBody>
       </p:sp>
@@ -6624,7 +6582,7 @@
           <a:noFill/>
         </p:spPr>
         <p:txBody>
-          <a:bodyPr wrap="square" anchor="t" lIns="0" rIns="0" tIns="0" bIns="0">
+          <a:bodyPr wrap="square" lIns="0" tIns="0" rIns="0" bIns="0" anchor="t">
             <a:spAutoFit/>
           </a:bodyPr>
           <a:lstStyle/>
@@ -6693,6 +6651,7 @@
           <a:lstStyle/>
           <a:p>
             <a:pPr algn="ctr"/>
+            <a:endParaRPr/>
           </a:p>
         </p:txBody>
       </p:sp>
@@ -6713,7 +6672,7 @@
           <a:noFill/>
         </p:spPr>
         <p:txBody>
-          <a:bodyPr wrap="square" anchor="ctr" lIns="0" rIns="0" tIns="0" bIns="0">
+          <a:bodyPr wrap="square" lIns="0" tIns="0" rIns="0" bIns="0" anchor="ctr">
             <a:spAutoFit/>
           </a:bodyPr>
           <a:lstStyle/>
@@ -6758,7 +6717,7 @@
           <a:noFill/>
         </p:spPr>
         <p:txBody>
-          <a:bodyPr wrap="square" anchor="ctr" lIns="0" rIns="0" tIns="0" bIns="0">
+          <a:bodyPr wrap="square" lIns="0" tIns="0" rIns="0" bIns="0" anchor="ctr">
             <a:spAutoFit/>
           </a:bodyPr>
           <a:lstStyle/>
@@ -6795,7 +6754,7 @@
 </file>
 
 <file path=ppt/slides/slide5.xml><?xml version="1.0" encoding="utf-8"?>
-<p:sld xmlns:a="http://schemas.openxmlformats.org/drawingml/2006/main" xmlns:p="http://schemas.openxmlformats.org/presentationml/2006/main" xmlns:r="http://schemas.openxmlformats.org/officeDocument/2006/relationships">
+<p:sld xmlns:a="http://schemas.openxmlformats.org/drawingml/2006/main" xmlns:r="http://schemas.openxmlformats.org/officeDocument/2006/relationships" xmlns:p="http://schemas.openxmlformats.org/presentationml/2006/main">
   <p:cSld>
     <p:spTree>
       <p:nvGrpSpPr>
@@ -6803,7 +6762,14 @@
         <p:cNvGrpSpPr/>
         <p:nvPr/>
       </p:nvGrpSpPr>
-      <p:grpSpPr/>
+      <p:grpSpPr>
+        <a:xfrm>
+          <a:off x="0" y="0"/>
+          <a:ext cx="0" cy="0"/>
+          <a:chOff x="0" y="0"/>
+          <a:chExt cx="0" cy="0"/>
+        </a:xfrm>
+      </p:grpSpPr>
       <p:sp>
         <p:nvSpPr>
           <p:cNvPr id="2" name="Rectangle 1"/>
@@ -6845,6 +6811,7 @@
           <a:lstStyle/>
           <a:p>
             <a:pPr algn="ctr"/>
+            <a:endParaRPr/>
           </a:p>
         </p:txBody>
       </p:sp>
@@ -6865,7 +6832,7 @@
           <a:noFill/>
         </p:spPr>
         <p:txBody>
-          <a:bodyPr wrap="square" anchor="ctr" lIns="0" rIns="0" tIns="0" bIns="0">
+          <a:bodyPr wrap="square" lIns="0" tIns="0" rIns="0" bIns="0" anchor="ctr">
             <a:spAutoFit/>
           </a:bodyPr>
           <a:lstStyle/>
@@ -6902,7 +6869,7 @@
           <p:nvPr/>
         </p:nvPicPr>
         <p:blipFill>
-          <a:blip r:embed="rId2"/>
+          <a:blip r:embed="rId3"/>
           <a:stretch>
             <a:fillRect/>
           </a:stretch>
@@ -6958,6 +6925,7 @@
           <a:lstStyle/>
           <a:p>
             <a:pPr algn="ctr"/>
+            <a:endParaRPr/>
           </a:p>
         </p:txBody>
       </p:sp>
@@ -7002,6 +6970,7 @@
           <a:lstStyle/>
           <a:p>
             <a:pPr algn="ctr"/>
+            <a:endParaRPr/>
           </a:p>
         </p:txBody>
       </p:sp>
@@ -7046,6 +7015,7 @@
           <a:lstStyle/>
           <a:p>
             <a:pPr algn="ctr"/>
+            <a:endParaRPr/>
           </a:p>
         </p:txBody>
       </p:sp>
@@ -7090,6 +7060,7 @@
           <a:lstStyle/>
           <a:p>
             <a:pPr algn="ctr"/>
+            <a:endParaRPr/>
           </a:p>
         </p:txBody>
       </p:sp>
@@ -7134,6 +7105,7 @@
           <a:lstStyle/>
           <a:p>
             <a:pPr algn="ctr"/>
+            <a:endParaRPr/>
           </a:p>
         </p:txBody>
       </p:sp>
@@ -7154,7 +7126,7 @@
           <a:noFill/>
         </p:spPr>
         <p:txBody>
-          <a:bodyPr wrap="square" anchor="t" lIns="0" rIns="0" tIns="0" bIns="0">
+          <a:bodyPr wrap="square" lIns="0" tIns="0" rIns="0" bIns="0" anchor="t">
             <a:spAutoFit/>
           </a:bodyPr>
           <a:lstStyle/>
@@ -7223,6 +7195,7 @@
           <a:lstStyle/>
           <a:p>
             <a:pPr algn="ctr"/>
+            <a:endParaRPr/>
           </a:p>
         </p:txBody>
       </p:sp>
@@ -7243,7 +7216,7 @@
           <a:noFill/>
         </p:spPr>
         <p:txBody>
-          <a:bodyPr wrap="square" anchor="t" lIns="0" rIns="0" tIns="0" bIns="0">
+          <a:bodyPr wrap="square" lIns="0" tIns="0" rIns="0" bIns="0" anchor="t">
             <a:spAutoFit/>
           </a:bodyPr>
           <a:lstStyle/>
@@ -7312,6 +7285,7 @@
           <a:lstStyle/>
           <a:p>
             <a:pPr algn="ctr"/>
+            <a:endParaRPr/>
           </a:p>
         </p:txBody>
       </p:sp>
@@ -7332,7 +7306,7 @@
           <a:noFill/>
         </p:spPr>
         <p:txBody>
-          <a:bodyPr wrap="square" anchor="t" lIns="0" rIns="0" tIns="0" bIns="0">
+          <a:bodyPr wrap="square" lIns="0" tIns="0" rIns="0" bIns="0" anchor="t">
             <a:spAutoFit/>
           </a:bodyPr>
           <a:lstStyle/>
@@ -7401,6 +7375,7 @@
           <a:lstStyle/>
           <a:p>
             <a:pPr algn="ctr"/>
+            <a:endParaRPr/>
           </a:p>
         </p:txBody>
       </p:sp>
@@ -7421,7 +7396,7 @@
           <a:noFill/>
         </p:spPr>
         <p:txBody>
-          <a:bodyPr wrap="square" anchor="ctr" lIns="0" rIns="0" tIns="0" bIns="0">
+          <a:bodyPr wrap="square" lIns="0" tIns="0" rIns="0" bIns="0" anchor="ctr">
             <a:spAutoFit/>
           </a:bodyPr>
           <a:lstStyle/>
@@ -7466,7 +7441,7 @@
           <a:noFill/>
         </p:spPr>
         <p:txBody>
-          <a:bodyPr wrap="square" anchor="ctr" lIns="0" rIns="0" tIns="0" bIns="0">
+          <a:bodyPr wrap="square" lIns="0" tIns="0" rIns="0" bIns="0" anchor="ctr">
             <a:spAutoFit/>
           </a:bodyPr>
           <a:lstStyle/>
@@ -7503,7 +7478,7 @@
 </file>
 
 <file path=ppt/slides/slide6.xml><?xml version="1.0" encoding="utf-8"?>
-<p:sld xmlns:a="http://schemas.openxmlformats.org/drawingml/2006/main" xmlns:p="http://schemas.openxmlformats.org/presentationml/2006/main" xmlns:r="http://schemas.openxmlformats.org/officeDocument/2006/relationships">
+<p:sld xmlns:a="http://schemas.openxmlformats.org/drawingml/2006/main" xmlns:r="http://schemas.openxmlformats.org/officeDocument/2006/relationships" xmlns:p="http://schemas.openxmlformats.org/presentationml/2006/main">
   <p:cSld>
     <p:spTree>
       <p:nvGrpSpPr>
@@ -7511,7 +7486,14 @@
         <p:cNvGrpSpPr/>
         <p:nvPr/>
       </p:nvGrpSpPr>
-      <p:grpSpPr/>
+      <p:grpSpPr>
+        <a:xfrm>
+          <a:off x="0" y="0"/>
+          <a:ext cx="0" cy="0"/>
+          <a:chOff x="0" y="0"/>
+          <a:chExt cx="0" cy="0"/>
+        </a:xfrm>
+      </p:grpSpPr>
       <p:sp>
         <p:nvSpPr>
           <p:cNvPr id="2" name="Rectangle 1"/>
@@ -7553,6 +7535,7 @@
           <a:lstStyle/>
           <a:p>
             <a:pPr algn="ctr"/>
+            <a:endParaRPr/>
           </a:p>
         </p:txBody>
       </p:sp>
@@ -7573,7 +7556,7 @@
           <a:noFill/>
         </p:spPr>
         <p:txBody>
-          <a:bodyPr wrap="square" anchor="ctr" lIns="0" rIns="0" tIns="0" bIns="0">
+          <a:bodyPr wrap="square" lIns="0" tIns="0" rIns="0" bIns="0" anchor="ctr">
             <a:spAutoFit/>
           </a:bodyPr>
           <a:lstStyle/>
@@ -7610,7 +7593,7 @@
           <p:nvPr/>
         </p:nvPicPr>
         <p:blipFill>
-          <a:blip r:embed="rId2"/>
+          <a:blip r:embed="rId3"/>
           <a:stretch>
             <a:fillRect/>
           </a:stretch>
@@ -7666,6 +7649,7 @@
           <a:lstStyle/>
           <a:p>
             <a:pPr algn="ctr"/>
+            <a:endParaRPr/>
           </a:p>
         </p:txBody>
       </p:sp>
@@ -7710,6 +7694,7 @@
           <a:lstStyle/>
           <a:p>
             <a:pPr algn="ctr"/>
+            <a:endParaRPr/>
           </a:p>
         </p:txBody>
       </p:sp>
@@ -7754,6 +7739,7 @@
           <a:lstStyle/>
           <a:p>
             <a:pPr algn="ctr"/>
+            <a:endParaRPr/>
           </a:p>
         </p:txBody>
       </p:sp>
@@ -7798,6 +7784,7 @@
           <a:lstStyle/>
           <a:p>
             <a:pPr algn="ctr"/>
+            <a:endParaRPr/>
           </a:p>
         </p:txBody>
       </p:sp>
@@ -7842,6 +7829,7 @@
           <a:lstStyle/>
           <a:p>
             <a:pPr algn="ctr"/>
+            <a:endParaRPr/>
           </a:p>
         </p:txBody>
       </p:sp>
@@ -7862,7 +7850,7 @@
           <a:noFill/>
         </p:spPr>
         <p:txBody>
-          <a:bodyPr wrap="square" anchor="t" lIns="0" rIns="0" tIns="0" bIns="0">
+          <a:bodyPr wrap="square" lIns="0" tIns="0" rIns="0" bIns="0" anchor="t">
             <a:spAutoFit/>
           </a:bodyPr>
           <a:lstStyle/>
@@ -7931,6 +7919,7 @@
           <a:lstStyle/>
           <a:p>
             <a:pPr algn="ctr"/>
+            <a:endParaRPr/>
           </a:p>
         </p:txBody>
       </p:sp>
@@ -7951,7 +7940,7 @@
           <a:noFill/>
         </p:spPr>
         <p:txBody>
-          <a:bodyPr wrap="square" anchor="t" lIns="0" rIns="0" tIns="0" bIns="0">
+          <a:bodyPr wrap="square" lIns="0" tIns="0" rIns="0" bIns="0" anchor="t">
             <a:spAutoFit/>
           </a:bodyPr>
           <a:lstStyle/>
@@ -8020,6 +8009,7 @@
           <a:lstStyle/>
           <a:p>
             <a:pPr algn="ctr"/>
+            <a:endParaRPr/>
           </a:p>
         </p:txBody>
       </p:sp>
@@ -8040,7 +8030,7 @@
           <a:noFill/>
         </p:spPr>
         <p:txBody>
-          <a:bodyPr wrap="square" anchor="t" lIns="0" rIns="0" tIns="0" bIns="0">
+          <a:bodyPr wrap="square" lIns="0" tIns="0" rIns="0" bIns="0" anchor="t">
             <a:spAutoFit/>
           </a:bodyPr>
           <a:lstStyle/>
@@ -8109,6 +8099,7 @@
           <a:lstStyle/>
           <a:p>
             <a:pPr algn="ctr"/>
+            <a:endParaRPr/>
           </a:p>
         </p:txBody>
       </p:sp>
@@ -8129,7 +8120,7 @@
           <a:noFill/>
         </p:spPr>
         <p:txBody>
-          <a:bodyPr wrap="square" anchor="ctr" lIns="0" rIns="0" tIns="0" bIns="0">
+          <a:bodyPr wrap="square" lIns="0" tIns="0" rIns="0" bIns="0" anchor="ctr">
             <a:spAutoFit/>
           </a:bodyPr>
           <a:lstStyle/>
@@ -8174,7 +8165,7 @@
           <a:noFill/>
         </p:spPr>
         <p:txBody>
-          <a:bodyPr wrap="square" anchor="ctr" lIns="0" rIns="0" tIns="0" bIns="0">
+          <a:bodyPr wrap="square" lIns="0" tIns="0" rIns="0" bIns="0" anchor="ctr">
             <a:spAutoFit/>
           </a:bodyPr>
           <a:lstStyle/>
@@ -8531,7 +8522,7 @@
 </file>
 
 <file path=ppt/theme/theme2.xml><?xml version="1.0" encoding="utf-8"?>
-<a:theme xmlns:a="http://schemas.openxmlformats.org/drawingml/2006/main" name="Office Theme">
+<a:theme xmlns:a="http://schemas.openxmlformats.org/drawingml/2006/main" name="Tema do Office">
   <a:themeElements>
     <a:clrScheme name="Office">
       <a:dk1>
@@ -8541,44 +8532,44 @@
         <a:sysClr val="window" lastClr="FFFFFF"/>
       </a:lt1>
       <a:dk2>
-        <a:srgbClr val="1F497D"/>
+        <a:srgbClr val="0E2841"/>
       </a:dk2>
       <a:lt2>
-        <a:srgbClr val="EEECE1"/>
+        <a:srgbClr val="E8E8E8"/>
       </a:lt2>
       <a:accent1>
-        <a:srgbClr val="4F81BD"/>
+        <a:srgbClr val="156082"/>
       </a:accent1>
       <a:accent2>
-        <a:srgbClr val="C0504D"/>
+        <a:srgbClr val="E97132"/>
       </a:accent2>
       <a:accent3>
-        <a:srgbClr val="9BBB59"/>
+        <a:srgbClr val="196B24"/>
       </a:accent3>
       <a:accent4>
-        <a:srgbClr val="8064A2"/>
+        <a:srgbClr val="0F9ED5"/>
       </a:accent4>
       <a:accent5>
-        <a:srgbClr val="4BACC6"/>
+        <a:srgbClr val="A02B93"/>
       </a:accent5>
       <a:accent6>
-        <a:srgbClr val="F79646"/>
+        <a:srgbClr val="4EA72E"/>
       </a:accent6>
       <a:hlink>
-        <a:srgbClr val="0000FF"/>
+        <a:srgbClr val="467886"/>
       </a:hlink>
       <a:folHlink>
-        <a:srgbClr val="800080"/>
+        <a:srgbClr val="96607D"/>
       </a:folHlink>
     </a:clrScheme>
     <a:fontScheme name="Office">
       <a:majorFont>
-        <a:latin typeface="Calibri"/>
+        <a:latin typeface="Aptos Display" panose="02110004020202020204"/>
         <a:ea typeface=""/>
         <a:cs typeface=""/>
-        <a:font script="Jpan" typeface="ＭＳ Ｐゴシック"/>
+        <a:font script="Jpan" typeface="游ゴシック Light"/>
         <a:font script="Hang" typeface="맑은 고딕"/>
-        <a:font script="Hans" typeface="宋体"/>
+        <a:font script="Hans" typeface="等线 Light"/>
         <a:font script="Hant" typeface="新細明體"/>
         <a:font script="Arab" typeface="Times New Roman"/>
         <a:font script="Hebr" typeface="Times New Roman"/>
@@ -8606,14 +8597,31 @@
         <a:font script="Viet" typeface="Times New Roman"/>
         <a:font script="Uigh" typeface="Microsoft Uighur"/>
         <a:font script="Geor" typeface="Sylfaen"/>
+        <a:font script="Armn" typeface="Arial"/>
+        <a:font script="Bugi" typeface="Leelawadee UI"/>
+        <a:font script="Bopo" typeface="Microsoft JhengHei"/>
+        <a:font script="Java" typeface="Javanese Text"/>
+        <a:font script="Lisu" typeface="Segoe UI"/>
+        <a:font script="Mymr" typeface="Myanmar Text"/>
+        <a:font script="Nkoo" typeface="Ebrima"/>
+        <a:font script="Olck" typeface="Nirmala UI"/>
+        <a:font script="Osma" typeface="Ebrima"/>
+        <a:font script="Phag" typeface="Phagspa"/>
+        <a:font script="Syrn" typeface="Estrangelo Edessa"/>
+        <a:font script="Syrj" typeface="Estrangelo Edessa"/>
+        <a:font script="Syre" typeface="Estrangelo Edessa"/>
+        <a:font script="Sora" typeface="Nirmala UI"/>
+        <a:font script="Tale" typeface="Microsoft Tai Le"/>
+        <a:font script="Talu" typeface="Microsoft New Tai Lue"/>
+        <a:font script="Tfng" typeface="Ebrima"/>
       </a:majorFont>
       <a:minorFont>
-        <a:latin typeface="Calibri"/>
+        <a:latin typeface="Aptos" panose="02110004020202020204"/>
         <a:ea typeface=""/>
         <a:cs typeface=""/>
-        <a:font script="Jpan" typeface="ＭＳ Ｐゴシック"/>
+        <a:font script="Jpan" typeface="游ゴシック"/>
         <a:font script="Hang" typeface="맑은 고딕"/>
-        <a:font script="Hans" typeface="宋体"/>
+        <a:font script="Hans" typeface="等线"/>
         <a:font script="Hant" typeface="新細明體"/>
         <a:font script="Arab" typeface="Arial"/>
         <a:font script="Hebr" typeface="Arial"/>
@@ -8641,6 +8649,23 @@
         <a:font script="Viet" typeface="Arial"/>
         <a:font script="Uigh" typeface="Microsoft Uighur"/>
         <a:font script="Geor" typeface="Sylfaen"/>
+        <a:font script="Armn" typeface="Arial"/>
+        <a:font script="Bugi" typeface="Leelawadee UI"/>
+        <a:font script="Bopo" typeface="Microsoft JhengHei"/>
+        <a:font script="Java" typeface="Javanese Text"/>
+        <a:font script="Lisu" typeface="Segoe UI"/>
+        <a:font script="Mymr" typeface="Myanmar Text"/>
+        <a:font script="Nkoo" typeface="Ebrima"/>
+        <a:font script="Olck" typeface="Nirmala UI"/>
+        <a:font script="Osma" typeface="Ebrima"/>
+        <a:font script="Phag" typeface="Phagspa"/>
+        <a:font script="Syrn" typeface="Estrangelo Edessa"/>
+        <a:font script="Syrj" typeface="Estrangelo Edessa"/>
+        <a:font script="Syre" typeface="Estrangelo Edessa"/>
+        <a:font script="Sora" typeface="Nirmala UI"/>
+        <a:font script="Tale" typeface="Microsoft Tai Le"/>
+        <a:font script="Talu" typeface="Microsoft New Tai Lue"/>
+        <a:font script="Tfng" typeface="Ebrima"/>
       </a:minorFont>
     </a:fontScheme>
     <a:fmtScheme name="Office">
@@ -8652,180 +8677,136 @@
           <a:gsLst>
             <a:gs pos="0">
               <a:schemeClr val="phClr">
-                <a:tint val="50000"/>
-                <a:satMod val="300000"/>
+                <a:lumMod val="110000"/>
+                <a:satMod val="105000"/>
+                <a:tint val="67000"/>
               </a:schemeClr>
             </a:gs>
-            <a:gs pos="35000">
+            <a:gs pos="50000">
               <a:schemeClr val="phClr">
-                <a:tint val="37000"/>
-                <a:satMod val="300000"/>
+                <a:lumMod val="105000"/>
+                <a:satMod val="103000"/>
+                <a:tint val="73000"/>
               </a:schemeClr>
             </a:gs>
             <a:gs pos="100000">
               <a:schemeClr val="phClr">
-                <a:tint val="15000"/>
-                <a:satMod val="350000"/>
+                <a:lumMod val="105000"/>
+                <a:satMod val="109000"/>
+                <a:tint val="81000"/>
               </a:schemeClr>
             </a:gs>
           </a:gsLst>
-          <a:lin ang="16200000" scaled="1"/>
+          <a:lin ang="5400000" scaled="0"/>
         </a:gradFill>
         <a:gradFill rotWithShape="1">
           <a:gsLst>
             <a:gs pos="0">
               <a:schemeClr val="phClr">
-                <a:tint val="100000"/>
+                <a:satMod val="103000"/>
+                <a:lumMod val="102000"/>
+                <a:tint val="94000"/>
+              </a:schemeClr>
+            </a:gs>
+            <a:gs pos="50000">
+              <a:schemeClr val="phClr">
+                <a:satMod val="110000"/>
+                <a:lumMod val="100000"/>
                 <a:shade val="100000"/>
-                <a:satMod val="130000"/>
               </a:schemeClr>
             </a:gs>
             <a:gs pos="100000">
               <a:schemeClr val="phClr">
-                <a:tint val="50000"/>
-                <a:shade val="100000"/>
-                <a:satMod val="350000"/>
+                <a:lumMod val="99000"/>
+                <a:satMod val="120000"/>
+                <a:shade val="78000"/>
               </a:schemeClr>
             </a:gs>
           </a:gsLst>
-          <a:lin ang="16200000" scaled="0"/>
+          <a:lin ang="5400000" scaled="0"/>
         </a:gradFill>
       </a:fillStyleLst>
       <a:lnStyleLst>
-        <a:ln w="9525" cap="flat" cmpd="sng" algn="ctr">
+        <a:ln w="12700" cap="flat" cmpd="sng" algn="ctr">
           <a:solidFill>
-            <a:schemeClr val="phClr">
-              <a:shade val="95000"/>
-              <a:satMod val="105000"/>
-            </a:schemeClr>
+            <a:schemeClr val="phClr"/>
           </a:solidFill>
           <a:prstDash val="solid"/>
+          <a:miter lim="800000"/>
+        </a:ln>
+        <a:ln w="19050" cap="flat" cmpd="sng" algn="ctr">
+          <a:solidFill>
+            <a:schemeClr val="phClr"/>
+          </a:solidFill>
+          <a:prstDash val="solid"/>
+          <a:miter lim="800000"/>
         </a:ln>
         <a:ln w="25400" cap="flat" cmpd="sng" algn="ctr">
           <a:solidFill>
             <a:schemeClr val="phClr"/>
           </a:solidFill>
           <a:prstDash val="solid"/>
-        </a:ln>
-        <a:ln w="38100" cap="flat" cmpd="sng" algn="ctr">
-          <a:solidFill>
-            <a:schemeClr val="phClr"/>
-          </a:solidFill>
-          <a:prstDash val="solid"/>
+          <a:miter lim="800000"/>
         </a:ln>
       </a:lnStyleLst>
       <a:effectStyleLst>
         <a:effectStyle>
+          <a:effectLst/>
+        </a:effectStyle>
+        <a:effectStyle>
+          <a:effectLst/>
+        </a:effectStyle>
+        <a:effectStyle>
           <a:effectLst>
-            <a:outerShdw blurRad="40000" dist="20000" dir="5400000" rotWithShape="0">
+            <a:outerShdw blurRad="57150" dist="19050" dir="5400000" algn="ctr" rotWithShape="0">
               <a:srgbClr val="000000">
-                <a:alpha val="38000"/>
+                <a:alpha val="63000"/>
               </a:srgbClr>
             </a:outerShdw>
           </a:effectLst>
-        </a:effectStyle>
-        <a:effectStyle>
-          <a:effectLst>
-            <a:outerShdw blurRad="40000" dist="23000" dir="5400000" rotWithShape="0">
-              <a:srgbClr val="000000">
-                <a:alpha val="35000"/>
-              </a:srgbClr>
-            </a:outerShdw>
-          </a:effectLst>
-        </a:effectStyle>
-        <a:effectStyle>
-          <a:effectLst>
-            <a:outerShdw blurRad="40000" dist="23000" dir="5400000" rotWithShape="0">
-              <a:srgbClr val="000000">
-                <a:alpha val="35000"/>
-              </a:srgbClr>
-            </a:outerShdw>
-          </a:effectLst>
-          <a:scene3d>
-            <a:camera prst="orthographicFront">
-              <a:rot lat="0" lon="0" rev="0"/>
-            </a:camera>
-            <a:lightRig rig="threePt" dir="t">
-              <a:rot lat="0" lon="0" rev="1200000"/>
-            </a:lightRig>
-          </a:scene3d>
-          <a:sp3d>
-            <a:bevelT w="63500" h="25400"/>
-          </a:sp3d>
         </a:effectStyle>
       </a:effectStyleLst>
       <a:bgFillStyleLst>
         <a:solidFill>
           <a:schemeClr val="phClr"/>
         </a:solidFill>
+        <a:solidFill>
+          <a:schemeClr val="phClr">
+            <a:tint val="95000"/>
+            <a:satMod val="170000"/>
+          </a:schemeClr>
+        </a:solidFill>
         <a:gradFill rotWithShape="1">
           <a:gsLst>
             <a:gs pos="0">
               <a:schemeClr val="phClr">
-                <a:tint val="40000"/>
-                <a:satMod val="350000"/>
+                <a:tint val="93000"/>
+                <a:satMod val="150000"/>
+                <a:shade val="98000"/>
+                <a:lumMod val="102000"/>
               </a:schemeClr>
             </a:gs>
-            <a:gs pos="40000">
+            <a:gs pos="50000">
               <a:schemeClr val="phClr">
-                <a:tint val="45000"/>
-                <a:shade val="99000"/>
-                <a:satMod val="350000"/>
+                <a:tint val="98000"/>
+                <a:satMod val="130000"/>
+                <a:shade val="90000"/>
+                <a:lumMod val="103000"/>
               </a:schemeClr>
             </a:gs>
             <a:gs pos="100000">
               <a:schemeClr val="phClr">
-                <a:shade val="20000"/>
-                <a:satMod val="255000"/>
+                <a:shade val="63000"/>
+                <a:satMod val="120000"/>
               </a:schemeClr>
             </a:gs>
           </a:gsLst>
-          <a:path path="circle">
-            <a:fillToRect l="50000" t="-80000" r="50000" b="180000"/>
-          </a:path>
-        </a:gradFill>
-        <a:gradFill rotWithShape="1">
-          <a:gsLst>
-            <a:gs pos="0">
-              <a:schemeClr val="phClr">
-                <a:tint val="80000"/>
-                <a:satMod val="300000"/>
-              </a:schemeClr>
-            </a:gs>
-            <a:gs pos="100000">
-              <a:schemeClr val="phClr">
-                <a:shade val="30000"/>
-                <a:satMod val="200000"/>
-              </a:schemeClr>
-            </a:gs>
-          </a:gsLst>
-          <a:path path="circle">
-            <a:fillToRect l="50000" t="50000" r="50000" b="50000"/>
-          </a:path>
+          <a:lin ang="5400000" scaled="0"/>
         </a:gradFill>
       </a:bgFillStyleLst>
     </a:fmtScheme>
   </a:themeElements>
   <a:objectDefaults>
-    <a:spDef>
-      <a:spPr/>
-      <a:bodyPr/>
-      <a:lstStyle/>
-      <a:style>
-        <a:lnRef idx="1">
-          <a:schemeClr val="accent1"/>
-        </a:lnRef>
-        <a:fillRef idx="3">
-          <a:schemeClr val="accent1"/>
-        </a:fillRef>
-        <a:effectRef idx="2">
-          <a:schemeClr val="accent1"/>
-        </a:effectRef>
-        <a:fontRef idx="minor">
-          <a:schemeClr val="lt1"/>
-        </a:fontRef>
-      </a:style>
-    </a:spDef>
     <a:lnDef>
       <a:spPr/>
       <a:bodyPr/>
@@ -8847,5 +8828,10 @@
     </a:lnDef>
   </a:objectDefaults>
   <a:extraClrSchemeLst/>
+  <a:extLst>
+    <a:ext uri="{05A4C25C-085E-4340-85A3-A5531E510DB2}">
+      <thm15:themeFamily xmlns:thm15="http://schemas.microsoft.com/office/thememl/2012/main" name="Office Theme" id="{2E142A2C-CD16-42D6-873A-C26D2A0506FA}" vid="{1BDDFF52-6CD6-40A5-AB3C-68EB2F1E4D0A}"/>
+    </a:ext>
+  </a:extLst>
 </a:theme>
 </file>
</xml_diff>